<commit_message>
Localize LLM token capacity report to Korean
</commit_message>
<xml_diff>
--- a/ai_scm_project/outputs/reports/llm_token_capacity_2026_2030.pptx
+++ b/ai_scm_project/outputs/reports/llm_token_capacity_2026_2030.pptx
@@ -136,7 +136,7 @@
               <c:strCache>
                 <c:ptCount val="1"/>
                 <c:pt idx="0">
-                  <c:v>2030 tokens/day (Q)</c:v>
+                  <c:v>2030 토큰/일 (Q)</c:v>
                 </c:pt>
               </c:strCache>
             </c:strRef>
@@ -276,7 +276,7 @@
               <c:strCache>
                 <c:ptCount val="1"/>
                 <c:pt idx="0">
-                  <c:v>Bear</c:v>
+                  <c:v>보수</c:v>
                 </c:pt>
               </c:strCache>
             </c:strRef>
@@ -339,7 +339,7 @@
               <c:strCache>
                 <c:ptCount val="1"/>
                 <c:pt idx="0">
-                  <c:v>Base</c:v>
+                  <c:v>기준</c:v>
                 </c:pt>
               </c:strCache>
             </c:strRef>
@@ -402,7 +402,7 @@
               <c:strCache>
                 <c:ptCount val="1"/>
                 <c:pt idx="0">
-                  <c:v>Bull</c:v>
+                  <c:v>낙관</c:v>
                 </c:pt>
               </c:strCache>
             </c:strRef>
@@ -465,7 +465,7 @@
               <c:strCache>
                 <c:ptCount val="1"/>
                 <c:pt idx="0">
-                  <c:v>Grid-Constrained / Efficiency-Upside</c:v>
+                  <c:v>전력제약·효율상승</c:v>
                 </c:pt>
               </c:strCache>
             </c:strRef>
@@ -626,19 +626,19 @@
               <c:strCache>
                 <c:ptCount val="5"/>
                 <c:pt idx="0">
-                  <c:v>Contracted</c:v>
+                  <c:v>계약</c:v>
                 </c:pt>
                 <c:pt idx="1">
-                  <c:v>Active</c:v>
+                  <c:v>가동</c:v>
                 </c:pt>
                 <c:pt idx="2">
                   <c:v>AI IT load</c:v>
                 </c:pt>
                 <c:pt idx="3">
-                  <c:v>Inference</c:v>
+                  <c:v>추론</c:v>
                 </c:pt>
                 <c:pt idx="4">
-                  <c:v>Training</c:v>
+                  <c:v>학습</c:v>
                 </c:pt>
               </c:strCache>
             </c:strRef>
@@ -755,7 +755,7 @@
               <c:strCache>
                 <c:ptCount val="1"/>
                 <c:pt idx="0">
-                  <c:v>Q tokens/day</c:v>
+                  <c:v>Q tokens/일</c:v>
                 </c:pt>
               </c:strCache>
             </c:strRef>
@@ -924,16 +924,16 @@
               <c:strCache>
                 <c:ptCount val="4"/>
                 <c:pt idx="0">
-                  <c:v>Bear</c:v>
+                  <c:v>보수</c:v>
                 </c:pt>
                 <c:pt idx="1">
-                  <c:v>Base</c:v>
+                  <c:v>기준</c:v>
                 </c:pt>
                 <c:pt idx="2">
-                  <c:v>Bull</c:v>
+                  <c:v>낙관</c:v>
                 </c:pt>
                 <c:pt idx="3">
-                  <c:v>Grid-constrained</c:v>
+                  <c:v>전력제약</c:v>
                 </c:pt>
               </c:strCache>
             </c:strRef>
@@ -980,16 +980,16 @@
               <c:strCache>
                 <c:ptCount val="4"/>
                 <c:pt idx="0">
-                  <c:v>Bear</c:v>
+                  <c:v>보수</c:v>
                 </c:pt>
                 <c:pt idx="1">
-                  <c:v>Base</c:v>
+                  <c:v>기준</c:v>
                 </c:pt>
                 <c:pt idx="2">
-                  <c:v>Bull</c:v>
+                  <c:v>낙관</c:v>
                 </c:pt>
                 <c:pt idx="3">
-                  <c:v>Grid-constrained</c:v>
+                  <c:v>전력제약</c:v>
                 </c:pt>
               </c:strCache>
             </c:strRef>
@@ -4090,7 +4090,7 @@
               </a:defRPr>
             </a:pPr>
             <a:r>
-              <a:t>EXECUTIVE SIMULATION</a:t>
+              <a:t>임원 보고용 시뮬레이션</a:t>
             </a:r>
           </a:p>
         </p:txBody>
@@ -4168,7 +4168,7 @@
               </a:defRPr>
             </a:pPr>
             <a:r>
-              <a:t>Model-owner 기준으로 OpenAI, Google, Meta, Microsoft, xAI, DeepSeek, Alibaba, Tencent의 inference capacity를 추정</a:t>
+              <a:t>모델 보유 업체 기준으로 OpenAI, Google, Meta, Microsoft, xAI, DeepSeek, Alibaba, Tencent의 추론 capacity를 추정</a:t>
             </a:r>
           </a:p>
         </p:txBody>
@@ -4222,7 +4222,7 @@
               </a:defRPr>
             </a:pPr>
             <a:r>
-              <a:t>2030 Base tokens/day</a:t>
+              <a:t>2030 기준 토큰/일</a:t>
             </a:r>
           </a:p>
           <a:p>
@@ -4300,7 +4300,7 @@
               </a:defRPr>
             </a:pPr>
             <a:r>
-              <a:t>2030 Base inference GW</a:t>
+              <a:t>2030 기준 추론 GW</a:t>
             </a:r>
           </a:p>
           <a:p>
@@ -4324,7 +4324,7 @@
               </a:defRPr>
             </a:pPr>
             <a:r>
-              <a:t>AI IT load 중 inference 배정</a:t>
+              <a:t>AI IT load 중 추론 배정</a:t>
             </a:r>
           </a:p>
         </p:txBody>
@@ -4378,7 +4378,7 @@
               </a:defRPr>
             </a:pPr>
             <a:r>
-              <a:t>Base inference share</a:t>
+              <a:t>기준 추론 비중</a:t>
             </a:r>
           </a:p>
           <a:p>
@@ -4402,7 +4402,7 @@
               </a:defRPr>
             </a:pPr>
             <a:r>
-              <a:t>2026은 fact가 아닌 scenario</a:t>
+              <a:t>2026은 fact가 아닌 시나리오</a:t>
             </a:r>
           </a:p>
         </p:txBody>
@@ -4437,7 +4437,7 @@
               </a:defRPr>
             </a:pPr>
             <a:r>
-              <a:t>핵심: 공개 fact는 capacity/model 규모를 제한하고, active GW·inference split·tokens/MW는 명시적 scenario로 둔다.</a:t>
+              <a:t>핵심: 공개 fact는 capacity/model 규모를 제한하고, active GW·추론 비중·tokens/MW는 명시적 시나리오로 둔다.</a:t>
             </a:r>
           </a:p>
         </p:txBody>
@@ -4472,7 +4472,7 @@
               </a:defRPr>
             </a:pPr>
             <a:r>
-              <a:t>Source-backed simulation | Fact / Estimate / Scenario separated | generated 2026-05-14</a:t>
+              <a:t>출처 기반 시뮬레이션 | Fact / Estimate / Scenario 분리 | 생성일 2026-05-14</a:t>
             </a:r>
           </a:p>
         </p:txBody>
@@ -4533,7 +4533,7 @@
               </a:defRPr>
             </a:pPr>
             <a:r>
-              <a:t>Memory marketing implications</a:t>
+              <a:t>메모리 마케팅 시사점</a:t>
             </a:r>
           </a:p>
         </p:txBody>
@@ -4568,7 +4568,7 @@
               </a:defRPr>
             </a:pPr>
             <a:r>
-              <a:t>Token capacity growth converts into allocation, qualification, and attach-rate motions.</a:t>
+              <a:t>토큰 capacity 성장은 allocation, qualification, attach-rate 영업 motion으로 전환된다.</a:t>
             </a:r>
           </a:p>
         </p:txBody>
@@ -4718,7 +4718,7 @@
               </a:defRPr>
             </a:pPr>
             <a:r>
-              <a:t>Inference fleet growth → CPU-side memory density and bandwidth attach story</a:t>
+              <a:t>추론 fleet 확대 → CPU-side memory density와 bandwidth attach story</a:t>
             </a:r>
           </a:p>
         </p:txBody>
@@ -4868,7 +4868,7 @@
               </a:defRPr>
             </a:pPr>
             <a:r>
-              <a:t>High-utilization inference clusters → memory expansion and utilization recovery</a:t>
+              <a:t>고가동률 추론 cluster → memory expansion과 utilization recovery</a:t>
             </a:r>
           </a:p>
         </p:txBody>
@@ -4903,7 +4903,7 @@
               </a:defRPr>
             </a:pPr>
             <a:r>
-              <a:t>Recommended sales motion: account brief by model owner, proof pack by memory product, and pricing/mix argument tied to scenario envelope.</a:t>
+              <a:t>권장 sales motion: model owner별 account brief, 제품별 proof pack, scenario envelope에 연결된 pricing/mix 논리.</a:t>
             </a:r>
           </a:p>
         </p:txBody>
@@ -4938,7 +4938,7 @@
               </a:defRPr>
             </a:pPr>
             <a:r>
-              <a:t>Source-backed simulation | Fact / Estimate / Scenario separated | generated 2026-05-14</a:t>
+              <a:t>출처 기반 시뮬레이션 | Fact / Estimate / Scenario 분리 | 생성일 2026-05-14</a:t>
             </a:r>
           </a:p>
         </p:txBody>
@@ -4999,7 +4999,7 @@
               </a:defRPr>
             </a:pPr>
             <a:r>
-              <a:t>Evidence confidence audit</a:t>
+              <a:t>근거 신뢰도 감사</a:t>
             </a:r>
           </a:p>
         </p:txBody>
@@ -5034,7 +5034,7 @@
               </a:defRPr>
             </a:pPr>
             <a:r>
-              <a:t>Strongest evidence is model size and announced capacity; weakest is active serving utilization.</a:t>
+              <a:t>가장 강한 근거는 모델 크기와 발표 capacity이며, 가장 약한 부분은 active serving utilization이다.</a:t>
             </a:r>
           </a:p>
         </p:txBody>
@@ -5069,7 +5069,7 @@
               </a:defRPr>
             </a:pPr>
             <a:r>
-              <a:t>High</a:t>
+              <a:t>높음</a:t>
             </a:r>
           </a:p>
         </p:txBody>
@@ -5104,7 +5104,7 @@
               </a:defRPr>
             </a:pPr>
             <a:r>
-              <a:t>Official model cards / technical reports</a:t>
+              <a:t>공식 model card / technical report</a:t>
             </a:r>
           </a:p>
         </p:txBody>
@@ -5174,7 +5174,7 @@
               </a:defRPr>
             </a:pPr>
             <a:r>
-              <a:t>Medium</a:t>
+              <a:t>중간</a:t>
             </a:r>
           </a:p>
         </p:txBody>
@@ -5209,7 +5209,7 @@
               </a:defRPr>
             </a:pPr>
             <a:r>
-              <a:t>Official capacity or hardware announcements</a:t>
+              <a:t>공식 capacity 또는 hardware 발표</a:t>
             </a:r>
           </a:p>
         </p:txBody>
@@ -5279,7 +5279,7 @@
               </a:defRPr>
             </a:pPr>
             <a:r>
-              <a:t>Low-Medium</a:t>
+              <a:t>낮음-중간</a:t>
             </a:r>
           </a:p>
         </p:txBody>
@@ -5314,7 +5314,7 @@
               </a:defRPr>
             </a:pPr>
             <a:r>
-              <a:t>Active GW and inference/training split</a:t>
+              <a:t>Active GW와 추론/학습 split</a:t>
             </a:r>
           </a:p>
         </p:txBody>
@@ -5349,7 +5349,7 @@
               </a:defRPr>
             </a:pPr>
             <a:r>
-              <a:t>requires telemetry or site-level disclosure</a:t>
+              <a:t>telemetry 또는 site-level disclosure 필요</a:t>
             </a:r>
           </a:p>
         </p:txBody>
@@ -5384,7 +5384,7 @@
               </a:defRPr>
             </a:pPr>
             <a:r>
-              <a:t>Sensitivity</a:t>
+              <a:t>민감도</a:t>
             </a:r>
           </a:p>
         </p:txBody>
@@ -5419,7 +5419,7 @@
               </a:defRPr>
             </a:pPr>
             <a:r>
-              <a:t>tokens/sec/MW and utilization</a:t>
+              <a:t>tokens/sec/MW와 utilization</a:t>
             </a:r>
           </a:p>
         </p:txBody>
@@ -5454,7 +5454,7 @@
               </a:defRPr>
             </a:pPr>
             <a:r>
-              <a:t>benchmarked as scenario, not company fact</a:t>
+              <a:t>company fact가 아니라 scenario benchmark</a:t>
             </a:r>
           </a:p>
         </p:txBody>
@@ -5489,7 +5489,7 @@
               </a:defRPr>
             </a:pPr>
             <a:r>
-              <a:t>Replacement path: site-level MW activation, model routing mix, production API traffic, and measured tokens/sec/MW by model/context.</a:t>
+              <a:t>Replacement path: site-level MW activation, model routing mix, production API traffic, 모델/context별 실측 tokens/sec/MW.</a:t>
             </a:r>
           </a:p>
         </p:txBody>
@@ -5524,7 +5524,7 @@
               </a:defRPr>
             </a:pPr>
             <a:r>
-              <a:t>Source-backed simulation | Fact / Estimate / Scenario separated | generated 2026-05-14</a:t>
+              <a:t>출처 기반 시뮬레이션 | Fact / Estimate / Scenario 분리 | 생성일 2026-05-14</a:t>
             </a:r>
           </a:p>
         </p:txBody>
@@ -5585,7 +5585,7 @@
               </a:defRPr>
             </a:pPr>
             <a:r>
-              <a:t>Appendix: exact calculation controls</a:t>
+              <a:t>부록: 계산 검증 컨트롤</a:t>
             </a:r>
           </a:p>
         </p:txBody>
@@ -5620,7 +5620,7 @@
               </a:defRPr>
             </a:pPr>
             <a:r>
-              <a:t>The workbook contains the full auditable model.</a:t>
+              <a:t>전체 감사 가능한 모델은 workbook에 수록되어 있다.</a:t>
             </a:r>
           </a:p>
         </p:txBody>
@@ -5658,7 +5658,7 @@
               </a:defRPr>
             </a:pPr>
             <a:r>
-              <a:t>00_formula_assumptions: every equation and how it should be interpreted.</a:t>
+              <a:t>00_formula_assumptions: 모든 계산식과 해석 방식.</a:t>
             </a:r>
           </a:p>
           <a:p>
@@ -5673,7 +5673,7 @@
               </a:defRPr>
             </a:pPr>
             <a:r>
-              <a:t>02a_fact_anchors: checked public numeric anchors, confidence, and replacement path.</a:t>
+              <a:t>02a_fact_anchors: 확인된 공개 numeric anchor, confidence, replacement path.</a:t>
             </a:r>
           </a:p>
           <a:p>
@@ -5688,7 +5688,7 @@
               </a:defRPr>
             </a:pPr>
             <a:r>
-              <a:t>08a/08b/08c: scenario definitions, company-year scenario forecast, and aggregate scenario summary.</a:t>
+              <a:t>08a/08b/08c: 시나리오 정의, 업체-연도별 forecast, aggregate scenario summary.</a:t>
             </a:r>
           </a:p>
           <a:p>
@@ -5703,7 +5703,7 @@
               </a:defRPr>
             </a:pPr>
             <a:r>
-              <a:t>Validation: active power does not exceed contracted power; training+inference equals 100%; displayed values recalculate token/day exactly.</a:t>
+              <a:t>Validation: active power는 contracted power 이하, 학습+추론=100%, 표시값으로 token/day 재계산 일치.</a:t>
             </a:r>
           </a:p>
         </p:txBody>
@@ -5738,7 +5738,7 @@
               </a:defRPr>
             </a:pPr>
             <a:r>
-              <a:t>Source-backed simulation | Fact / Estimate / Scenario separated | generated 2026-05-14</a:t>
+              <a:t>출처 기반 시뮬레이션 | Fact / Estimate / Scenario 분리 | 생성일 2026-05-14</a:t>
             </a:r>
           </a:p>
         </p:txBody>
@@ -5799,7 +5799,7 @@
               </a:defRPr>
             </a:pPr>
             <a:r>
-              <a:t>Executive conclusion</a:t>
+              <a:t>임원 요약 결론</a:t>
             </a:r>
           </a:p>
         </p:txBody>
@@ -5834,7 +5834,7 @@
               </a:defRPr>
             </a:pPr>
             <a:r>
-              <a:t>Base case는 2026 0.19Q/day에서 2030 2.55Q/day로 확대되지만, 신뢰도는 capacity activation과 serving efficiency에 좌우됩니다.</a:t>
+              <a:t>기준 시나리오는 2026년 0.19Q/day에서 2030년 2.55Q/day로 확대되지만, 신뢰도는 전력 가동과 serving 효율에 좌우됩니다.</a:t>
             </a:r>
           </a:p>
         </p:txBody>
@@ -5872,7 +5872,7 @@
               </a:defRPr>
             </a:pPr>
             <a:r>
-              <a:t>OpenAI·Google·Meta가 2030 Base token capacity의 상위권을 형성한다.</a:t>
+              <a:t>OpenAI·Google·Meta가 2030년 기준 토큰 capacity의 상위권을 형성한다.</a:t>
             </a:r>
           </a:p>
           <a:p>
@@ -5887,7 +5887,7 @@
               </a:defRPr>
             </a:pPr>
             <a:r>
-              <a:t>2026 inference 60%+는 공식 fact가 아니므로 Base는 56%, Bull만 61%로 제한했다.</a:t>
+              <a:t>2026년 추론 60%+는 공식 fact가 아니므로 기준은 56%, 낙관만 61%로 제한했다.</a:t>
             </a:r>
           </a:p>
           <a:p>
@@ -5902,7 +5902,7 @@
               </a:defRPr>
             </a:pPr>
             <a:r>
-              <a:t>2030 Base inference share 76%는 commercial serving 확대를 반영하되, training GW를 계속 남긴다.</a:t>
+              <a:t>2030년 기준 추론 비중 76%는 상용 serving 확대를 반영하되, 학습 GW를 계속 남긴다.</a:t>
             </a:r>
           </a:p>
           <a:p>
@@ -5917,7 +5917,7 @@
               </a:defRPr>
             </a:pPr>
             <a:r>
-              <a:t>MoE 공개 모델 DeepSeek/Qwen은 parameter evidence가 강하지만, active capacity transparency는 낮다.</a:t>
+              <a:t>MoE 공개 모델 DeepSeek/Qwen은 파라미터 근거가 강하지만, active capacity 투명성은 낮다.</a:t>
             </a:r>
           </a:p>
         </p:txBody>
@@ -5970,7 +5970,7 @@
               </a:defRPr>
             </a:pPr>
             <a:r>
-              <a:t>2030 Base company ranking, quadrillion tokens/day</a:t>
+              <a:t>2030 기준 업체 순위, quadrillion tokens/day</a:t>
             </a:r>
           </a:p>
         </p:txBody>
@@ -6005,7 +6005,7 @@
               </a:defRPr>
             </a:pPr>
             <a:r>
-              <a:t>Source-backed simulation | Fact / Estimate / Scenario separated | generated 2026-05-14</a:t>
+              <a:t>출처 기반 시뮬레이션 | Fact / Estimate / Scenario 분리 | 생성일 2026-05-14</a:t>
             </a:r>
           </a:p>
         </p:txBody>
@@ -6066,7 +6066,7 @@
               </a:defRPr>
             </a:pPr>
             <a:r>
-              <a:t>계산 로직은 전력 funnel과 serving efficiency의 곱</a:t>
+              <a:t>계산 로직은 전력 funnel과 serving 효율의 곱</a:t>
             </a:r>
           </a:p>
         </p:txBody>
@@ -6101,7 +6101,7 @@
               </a:defRPr>
             </a:pPr>
             <a:r>
-              <a:t>계약 전력은 token capacity가 아니며, active power와 AI IT load를 거쳐 inference GW로 내려옵니다.</a:t>
+              <a:t>계약 전력은 token capacity가 아니며, 가동 전력과 AI IT load를 거쳐 추론 GW로 내려옵니다.</a:t>
             </a:r>
           </a:p>
         </p:txBody>
@@ -6155,7 +6155,7 @@
               </a:defRPr>
             </a:pPr>
             <a:r>
-              <a:t>1. Contracted power</a:t>
+              <a:t>1. 계약 전력</a:t>
             </a:r>
           </a:p>
           <a:p>
@@ -6260,7 +6260,7 @@
               </a:defRPr>
             </a:pPr>
             <a:r>
-              <a:t>2. Active power</a:t>
+              <a:t>2. 가동 전력</a:t>
             </a:r>
           </a:p>
           <a:p>
@@ -6276,7 +6276,7 @@
             </a:r>
             <a:br/>
             <a:r>
-              <a:t>scenario</a:t>
+              <a:t>시나리오</a:t>
             </a:r>
           </a:p>
         </p:txBody>
@@ -6470,7 +6470,7 @@
               </a:defRPr>
             </a:pPr>
             <a:r>
-              <a:t>4. Inference GW</a:t>
+              <a:t>4. 추론 GW</a:t>
             </a:r>
           </a:p>
           <a:p>
@@ -6482,7 +6482,7 @@
               </a:defRPr>
             </a:pPr>
             <a:r>
-              <a:t>training/inference</a:t>
+              <a:t>학습/추론</a:t>
             </a:r>
             <a:br/>
             <a:r>
@@ -6575,7 +6575,7 @@
               </a:defRPr>
             </a:pPr>
             <a:r>
-              <a:t>5. Tokens/day</a:t>
+              <a:t>5. 토큰/일</a:t>
             </a:r>
           </a:p>
           <a:p>
@@ -6626,7 +6626,7 @@
               </a:defRPr>
             </a:pPr>
             <a:r>
-              <a:t>inference_tokens_per_day = inference_gw × 1,000 × tokens_per_second_per_mw × utilization × 86,400</a:t>
+              <a:t>추론 토큰/일 = 추론 GW × 1,000 × tokens/sec/MW × utilization × 86,400</a:t>
             </a:r>
           </a:p>
         </p:txBody>
@@ -6664,7 +6664,7 @@
               </a:defRPr>
             </a:pPr>
             <a:r>
-              <a:t>Excel/JSON 표시값 기준 재계산도 일치하도록 rounding 후 token 산식을 적용했다.</a:t>
+              <a:t>Excel/JSON 표시값 기준 재계산도 일치하도록 rounding 후 토큰 산식을 적용했다.</a:t>
             </a:r>
           </a:p>
           <a:p>
@@ -6714,7 +6714,7 @@
               </a:defRPr>
             </a:pPr>
             <a:r>
-              <a:t>Source-backed simulation | Fact / Estimate / Scenario separated | generated 2026-05-14</a:t>
+              <a:t>출처 기반 시뮬레이션 | Fact / Estimate / Scenario 분리 | 생성일 2026-05-14</a:t>
             </a:r>
           </a:p>
         </p:txBody>
@@ -6775,7 +6775,7 @@
               </a:defRPr>
             </a:pPr>
             <a:r>
-              <a:t>시나리오별 token capacity envelope</a:t>
+              <a:t>시나리오별 토큰 capacity 범위</a:t>
             </a:r>
           </a:p>
         </p:txBody>
@@ -6810,7 +6810,7 @@
               </a:defRPr>
             </a:pPr>
             <a:r>
-              <a:t>Bull/Base/Bear는 deployment speed, inference mix, MoE/serving efficiency를 동시에 움직입니다.</a:t>
+              <a:t>낙관/기준/보수 시나리오는 전력 가동 속도, 추론 비중, MoE·serving 효율을 동시에 움직입니다.</a:t>
             </a:r>
           </a:p>
         </p:txBody>
@@ -6882,7 +6882,7 @@
               </a:defRPr>
             </a:pPr>
             <a:r>
-              <a:t>Bear</a:t>
+              <a:t>보수</a:t>
             </a:r>
           </a:p>
           <a:p>
@@ -6894,7 +6894,7 @@
               </a:defRPr>
             </a:pPr>
             <a:r>
-              <a:t>1.33Q/day</a:t>
+              <a:t>1.33Q/일</a:t>
             </a:r>
           </a:p>
           <a:p>
@@ -6906,7 +6906,7 @@
               </a:defRPr>
             </a:pPr>
             <a:r>
-              <a:t>2030 share 66%</a:t>
+              <a:t>2030 비중 66%</a:t>
             </a:r>
           </a:p>
         </p:txBody>
@@ -6960,7 +6960,7 @@
               </a:defRPr>
             </a:pPr>
             <a:r>
-              <a:t>Base</a:t>
+              <a:t>기준</a:t>
             </a:r>
           </a:p>
           <a:p>
@@ -6972,7 +6972,7 @@
               </a:defRPr>
             </a:pPr>
             <a:r>
-              <a:t>2.55Q/day</a:t>
+              <a:t>2.55Q/일</a:t>
             </a:r>
           </a:p>
           <a:p>
@@ -6984,7 +6984,7 @@
               </a:defRPr>
             </a:pPr>
             <a:r>
-              <a:t>2030 share 76%</a:t>
+              <a:t>2030 비중 76%</a:t>
             </a:r>
           </a:p>
         </p:txBody>
@@ -7038,7 +7038,7 @@
               </a:defRPr>
             </a:pPr>
             <a:r>
-              <a:t>Bull</a:t>
+              <a:t>낙관</a:t>
             </a:r>
           </a:p>
           <a:p>
@@ -7050,7 +7050,7 @@
               </a:defRPr>
             </a:pPr>
             <a:r>
-              <a:t>4.27Q/day</a:t>
+              <a:t>4.27Q/일</a:t>
             </a:r>
           </a:p>
           <a:p>
@@ -7062,7 +7062,7 @@
               </a:defRPr>
             </a:pPr>
             <a:r>
-              <a:t>2030 share 84%</a:t>
+              <a:t>2030 비중 84%</a:t>
             </a:r>
           </a:p>
         </p:txBody>
@@ -7116,7 +7116,7 @@
               </a:defRPr>
             </a:pPr>
             <a:r>
-              <a:t>Grid-Constrained / Efficiency-Upside</a:t>
+              <a:t>전력제약·효율상승</a:t>
             </a:r>
           </a:p>
           <a:p>
@@ -7128,7 +7128,7 @@
               </a:defRPr>
             </a:pPr>
             <a:r>
-              <a:t>2.40Q/day</a:t>
+              <a:t>2.40Q/일</a:t>
             </a:r>
           </a:p>
           <a:p>
@@ -7140,7 +7140,7 @@
               </a:defRPr>
             </a:pPr>
             <a:r>
-              <a:t>2030 share 80%</a:t>
+              <a:t>2030 비중 80%</a:t>
             </a:r>
           </a:p>
         </p:txBody>
@@ -7175,7 +7175,7 @@
               </a:defRPr>
             </a:pPr>
             <a:r>
-              <a:t>Source-backed simulation | Fact / Estimate / Scenario separated | generated 2026-05-14</a:t>
+              <a:t>출처 기반 시뮬레이션 | Fact / Estimate / Scenario 분리 | 생성일 2026-05-14</a:t>
             </a:r>
           </a:p>
         </p:txBody>
@@ -7236,7 +7236,7 @@
               </a:defRPr>
             </a:pPr>
             <a:r>
-              <a:t>2030 Base power funnel</a:t>
+              <a:t>2030 기준 전력 전환 구조</a:t>
             </a:r>
           </a:p>
         </p:txBody>
@@ -7271,7 +7271,7 @@
               </a:defRPr>
             </a:pPr>
             <a:r>
-              <a:t>Token capacity는 contracted power가 아니라 inference GW에서 나온다.</a:t>
+              <a:t>토큰 capacity는 계약 전력이 아니라 실제 추론 GW에서 나온다.</a:t>
             </a:r>
           </a:p>
         </p:txBody>
@@ -7343,7 +7343,7 @@
               </a:defRPr>
             </a:pPr>
             <a:r>
-              <a:t>Contracted → Active</a:t>
+              <a:t>계약 → 가동</a:t>
             </a:r>
           </a:p>
           <a:p>
@@ -7421,7 +7421,7 @@
               </a:defRPr>
             </a:pPr>
             <a:r>
-              <a:t>AI IT → Inference</a:t>
+              <a:t>AI IT → 추론</a:t>
             </a:r>
           </a:p>
           <a:p>
@@ -7445,7 +7445,7 @@
               </a:defRPr>
             </a:pPr>
             <a:r>
-              <a:t>Base 2030 split</a:t>
+              <a:t>2030 기준 split</a:t>
             </a:r>
           </a:p>
         </p:txBody>
@@ -7499,7 +7499,7 @@
               </a:defRPr>
             </a:pPr>
             <a:r>
-              <a:t>Training remains</a:t>
+              <a:t>학습 잔존</a:t>
             </a:r>
           </a:p>
           <a:p>
@@ -7523,7 +7523,7 @@
               </a:defRPr>
             </a:pPr>
             <a:r>
-              <a:t>not assumed to vanish</a:t>
+              <a:t>0으로 가정하지 않음</a:t>
             </a:r>
           </a:p>
         </p:txBody>
@@ -7558,7 +7558,7 @@
               </a:defRPr>
             </a:pPr>
             <a:r>
-              <a:t>Source-backed simulation | Fact / Estimate / Scenario separated | generated 2026-05-14</a:t>
+              <a:t>출처 기반 시뮬레이션 | Fact / Estimate / Scenario 분리 | 생성일 2026-05-14</a:t>
             </a:r>
           </a:p>
         </p:txBody>
@@ -7619,7 +7619,7 @@
               </a:defRPr>
             </a:pPr>
             <a:r>
-              <a:t>2030 Base token capacity by model owner</a:t>
+              <a:t>2030 기준 모델 보유 업체별 토큰 capacity</a:t>
             </a:r>
           </a:p>
         </p:txBody>
@@ -7654,7 +7654,7 @@
               </a:defRPr>
             </a:pPr>
             <a:r>
-              <a:t>Host capacity is attributed back to the model owner where model ownership is clear.</a:t>
+              <a:t>호스팅 capacity는 모델 소유권이 명확한 경우 model owner 기준으로 귀속한다.</a:t>
             </a:r>
           </a:p>
         </p:txBody>
@@ -7707,7 +7707,7 @@
               </a:defRPr>
             </a:pPr>
             <a:r>
-              <a:t>Microsoft/OpenAI overlap: OpenAI model output is counted under OpenAI model-owner logic; Microsoft row captures Microsoft-owned/serving burden assumptions.</a:t>
+              <a:t>Microsoft/OpenAI 중복 처리: OpenAI 모델 output은 OpenAI model-owner로 귀속하고, Microsoft row는 Microsoft-owned/serving burden 가정을 반영한다.</a:t>
             </a:r>
           </a:p>
         </p:txBody>
@@ -7742,7 +7742,7 @@
               </a:defRPr>
             </a:pPr>
             <a:r>
-              <a:t>Source-backed simulation | Fact / Estimate / Scenario separated | generated 2026-05-14</a:t>
+              <a:t>출처 기반 시뮬레이션 | Fact / Estimate / Scenario 분리 | 생성일 2026-05-14</a:t>
             </a:r>
           </a:p>
         </p:txBody>
@@ -7803,7 +7803,7 @@
               </a:defRPr>
             </a:pPr>
             <a:r>
-              <a:t>Fact anchors tighten the model, but do not replace telemetry</a:t>
+              <a:t>Fact anchor는 모델을 조여주지만 telemetry를 대체하지 않는다</a:t>
             </a:r>
           </a:p>
         </p:txBody>
@@ -7838,7 +7838,7 @@
               </a:defRPr>
             </a:pPr>
             <a:r>
-              <a:t>Public facts constrain model size and capacity ceilings; active GW and utilization remain estimates.</a:t>
+              <a:t>공개 fact는 모델 규모와 capacity 상한을 제한하고, active GW와 utilization은 여전히 추정치다.</a:t>
             </a:r>
           </a:p>
         </p:txBody>
@@ -7904,7 +7904,7 @@
               </a:defRPr>
             </a:pPr>
             <a:r>
-              <a:t>4.5GW Oracle + 10GW Stargate</a:t>
+              <a:t>Oracle 4.5GW + Stargate 10GW</a:t>
             </a:r>
           </a:p>
           <a:p>
@@ -7916,7 +7916,7 @@
               </a:defRPr>
             </a:pPr>
             <a:r>
-              <a:t>capacity ceiling</a:t>
+              <a:t>capacity 상한</a:t>
             </a:r>
           </a:p>
         </p:txBody>
@@ -8072,7 +8072,7 @@
               </a:defRPr>
             </a:pPr>
             <a:r>
-              <a:t>MoE efficiency</a:t>
+              <a:t>MoE 효율</a:t>
             </a:r>
           </a:p>
         </p:txBody>
@@ -8150,7 +8150,7 @@
               </a:defRPr>
             </a:pPr>
             <a:r>
-              <a:t>MoE efficiency</a:t>
+              <a:t>MoE 효율</a:t>
             </a:r>
           </a:p>
         </p:txBody>
@@ -8450,7 +8450,7 @@
               </a:defRPr>
             </a:pPr>
             <a:r>
-              <a:t>Llama 4 109B/400B with 17B active</a:t>
+              <a:t>Llama 4 109B/400B, 17B active</a:t>
             </a:r>
           </a:p>
           <a:p>
@@ -8497,7 +8497,7 @@
               </a:defRPr>
             </a:pPr>
             <a:r>
-              <a:t>Sources listed in Excel 01_sources and 02a_fact_anchors | generated 2026-05-14</a:t>
+              <a:t>상세 출처는 Excel 01_sources 및 02a_fact_anchors에 수록 | 생성일 2026-05-14</a:t>
             </a:r>
           </a:p>
         </p:txBody>
@@ -8558,7 +8558,7 @@
               </a:defRPr>
             </a:pPr>
             <a:r>
-              <a:t>Inference share fact-check</a:t>
+              <a:t>추론 비중 fact-check</a:t>
             </a:r>
           </a:p>
         </p:txBody>
@@ -8593,7 +8593,7 @@
               </a:defRPr>
             </a:pPr>
             <a:r>
-              <a:t>The model no longer treats 2026 60%+ inference GW as a fact.</a:t>
+              <a:t>이 모델은 2026년 60%+ 추론 GW를 fact로 취급하지 않는다.</a:t>
             </a:r>
           </a:p>
         </p:txBody>
@@ -8649,7 +8649,7 @@
               </a:defRPr>
             </a:pPr>
             <a:r>
-              <a:t>Base 2026: 56%, below 60%.</a:t>
+              <a:t>기준 2026: 56%, 60% 미만.</a:t>
             </a:r>
           </a:p>
           <a:p>
@@ -8664,7 +8664,7 @@
               </a:defRPr>
             </a:pPr>
             <a:r>
-              <a:t>Bull 2026: 61%, allowed as upside scenario only.</a:t>
+              <a:t>낙관 2026: 61%, upside scenario에서만 허용.</a:t>
             </a:r>
           </a:p>
           <a:p>
@@ -8679,7 +8679,7 @@
               </a:defRPr>
             </a:pPr>
             <a:r>
-              <a:t>Base 2030: 76%, reflecting commercial serving growth.</a:t>
+              <a:t>기준 2030: 76%, 상용 serving 확대 반영.</a:t>
             </a:r>
           </a:p>
           <a:p>
@@ -8694,7 +8694,7 @@
               </a:defRPr>
             </a:pPr>
             <a:r>
-              <a:t>Training capacity remains material in every case.</a:t>
+              <a:t>모든 case에서 학습 capacity는 계속 유의미하게 남김.</a:t>
             </a:r>
           </a:p>
         </p:txBody>
@@ -8729,7 +8729,7 @@
               </a:defRPr>
             </a:pPr>
             <a:r>
-              <a:t>Source-backed simulation | Fact / Estimate / Scenario separated | generated 2026-05-14</a:t>
+              <a:t>출처 기반 시뮬레이션 | Fact / Estimate / Scenario 분리 | 생성일 2026-05-14</a:t>
             </a:r>
           </a:p>
         </p:txBody>
@@ -8790,7 +8790,7 @@
               </a:defRPr>
             </a:pPr>
             <a:r>
-              <a:t>Model-owner landscape</a:t>
+              <a:t>모델 보유 업체 landscape</a:t>
             </a:r>
           </a:p>
         </p:txBody>
@@ -8825,7 +8825,7 @@
               </a:defRPr>
             </a:pPr>
             <a:r>
-              <a:t>Core rows are commercial LLM owners, not datacenter hosts.</a:t>
+              <a:t>Core row는 데이터센터 host가 아니라 상용 LLM owner다.</a:t>
             </a:r>
           </a:p>
         </p:txBody>
@@ -8905,7 +8905,7 @@
               </a:defRPr>
             </a:pPr>
             <a:r>
-              <a:t>US scaled platforms</a:t>
+              <a:t>미국 대형 플랫폼</a:t>
             </a:r>
           </a:p>
         </p:txBody>
@@ -9265,7 +9265,7 @@
               </a:defRPr>
             </a:pPr>
             <a:r>
-              <a:t>US challenger</a:t>
+              <a:t>미국 challenger</a:t>
             </a:r>
           </a:p>
         </p:txBody>
@@ -9415,7 +9415,7 @@
               </a:defRPr>
             </a:pPr>
             <a:r>
-              <a:t>China model owners</a:t>
+              <a:t>중국 model owner</a:t>
             </a:r>
           </a:p>
         </p:txBody>
@@ -9660,7 +9660,7 @@
               </a:defRPr>
             </a:pPr>
             <a:r>
-              <a:t>Source-backed simulation | Fact / Estimate / Scenario separated | generated 2026-05-14</a:t>
+              <a:t>출처 기반 시뮬레이션 | Fact / Estimate / Scenario 분리 | 생성일 2026-05-14</a:t>
             </a:r>
           </a:p>
         </p:txBody>

</xml_diff>

<commit_message>
Add Anthropic benchmark and hallucination audit
</commit_message>
<xml_diff>
--- a/ai_scm_project/outputs/reports/llm_token_capacity_2026_2030.pptx
+++ b/ai_scm_project/outputs/reports/llm_token_capacity_2026_2030.pptx
@@ -17,6 +17,8 @@
     <p:sldId id="265" r:id="rId16"/>
     <p:sldId id="266" r:id="rId17"/>
     <p:sldId id="267" r:id="rId18"/>
+    <p:sldId id="268" r:id="rId19"/>
+    <p:sldId id="269" r:id="rId20"/>
   </p:sldIdLst>
   <p:sldSz cx="12191695" cy="6858000" type="screen4x3"/>
   <p:notesSz cx="6858000" cy="9144000"/>
@@ -159,7 +161,7 @@
                   <c:v>Microsoft</c:v>
                 </c:pt>
                 <c:pt idx="4">
-                  <c:v>Alibaba</c:v>
+                  <c:v>Anthropic</c:v>
                 </c:pt>
               </c:strCache>
             </c:strRef>
@@ -183,7 +185,7 @@
                   <c:v>0.372288096107136</c:v>
                 </c:pt>
                 <c:pt idx="4">
-                  <c:v>0.259801314859008</c:v>
+                  <c:v>0.31830324515136</c:v>
                 </c:pt>
               </c:numCache>
             </c:numRef>
@@ -311,19 +313,19 @@
                 <c:formatCode>General</c:formatCode>
                 <c:ptCount val="5"/>
                 <c:pt idx="0">
-                  <c:v>0.108</c:v>
+                  <c:v>0.117</c:v>
                 </c:pt>
                 <c:pt idx="1">
-                  <c:v>0.257</c:v>
+                  <c:v>0.286</c:v>
                 </c:pt>
                 <c:pt idx="2">
-                  <c:v>0.488</c:v>
+                  <c:v>0.546</c:v>
                 </c:pt>
                 <c:pt idx="3">
-                  <c:v>0.832</c:v>
+                  <c:v>0.934</c:v>
                 </c:pt>
                 <c:pt idx="4">
-                  <c:v>1.327</c:v>
+                  <c:v>1.494</c:v>
                 </c:pt>
               </c:numCache>
             </c:numRef>
@@ -374,19 +376,19 @@
                 <c:formatCode>General</c:formatCode>
                 <c:ptCount val="5"/>
                 <c:pt idx="0">
-                  <c:v>0.19</c:v>
+                  <c:v>0.208</c:v>
                 </c:pt>
                 <c:pt idx="1">
-                  <c:v>0.464</c:v>
+                  <c:v>0.516</c:v>
                 </c:pt>
                 <c:pt idx="2">
-                  <c:v>0.9</c:v>
+                  <c:v>1.006</c:v>
                 </c:pt>
                 <c:pt idx="3">
-                  <c:v>1.566</c:v>
+                  <c:v>1.757</c:v>
                 </c:pt>
                 <c:pt idx="4">
-                  <c:v>2.554</c:v>
+                  <c:v>2.872</c:v>
                 </c:pt>
               </c:numCache>
             </c:numRef>
@@ -437,19 +439,19 @@
                 <c:formatCode>General</c:formatCode>
                 <c:ptCount val="5"/>
                 <c:pt idx="0">
-                  <c:v>0.277</c:v>
+                  <c:v>0.302</c:v>
                 </c:pt>
                 <c:pt idx="1">
-                  <c:v>0.703</c:v>
+                  <c:v>0.779</c:v>
                 </c:pt>
                 <c:pt idx="2">
-                  <c:v>1.411</c:v>
+                  <c:v>1.575</c:v>
                 </c:pt>
                 <c:pt idx="3">
-                  <c:v>2.537</c:v>
+                  <c:v>2.84</c:v>
                 </c:pt>
                 <c:pt idx="4">
-                  <c:v>4.269</c:v>
+                  <c:v>4.79</c:v>
                 </c:pt>
               </c:numCache>
             </c:numRef>
@@ -500,19 +502,19 @@
                 <c:formatCode>General</c:formatCode>
                 <c:ptCount val="5"/>
                 <c:pt idx="0">
-                  <c:v>0.213</c:v>
+                  <c:v>0.233</c:v>
                 </c:pt>
                 <c:pt idx="1">
-                  <c:v>0.502</c:v>
+                  <c:v>0.556</c:v>
                 </c:pt>
                 <c:pt idx="2">
-                  <c:v>0.932</c:v>
+                  <c:v>1.039</c:v>
                 </c:pt>
                 <c:pt idx="3">
-                  <c:v>1.548</c:v>
+                  <c:v>1.732</c:v>
                 </c:pt>
                 <c:pt idx="4">
-                  <c:v>2.402</c:v>
+                  <c:v>2.693</c:v>
                 </c:pt>
               </c:numCache>
             </c:numRef>
@@ -650,19 +652,19 @@
                 <c:formatCode>General</c:formatCode>
                 <c:ptCount val="5"/>
                 <c:pt idx="0">
-                  <c:v>47.8</c:v>
+                  <c:v>54.8</c:v>
                 </c:pt>
                 <c:pt idx="1">
-                  <c:v>36.6</c:v>
+                  <c:v>42.1</c:v>
                 </c:pt>
                 <c:pt idx="2">
-                  <c:v>26.311999999999998</c:v>
+                  <c:v>30.32</c:v>
                 </c:pt>
                 <c:pt idx="3">
-                  <c:v>20.055</c:v>
+                  <c:v>23.021</c:v>
                 </c:pt>
                 <c:pt idx="4">
-                  <c:v>6.258</c:v>
+                  <c:v>7.3</c:v>
                 </c:pt>
               </c:numCache>
             </c:numRef>
@@ -762,9 +764,9 @@
           </c:tx>
           <c:cat>
             <c:strRef>
-              <c:f>Sheet1!$A$2:$A$9</c:f>
+              <c:f>Sheet1!$A$2:$A$10</c:f>
               <c:strCache>
-                <c:ptCount val="8"/>
+                <c:ptCount val="9"/>
                 <c:pt idx="0">
                   <c:v>OpenAI</c:v>
                 </c:pt>
@@ -778,15 +780,18 @@
                   <c:v>Microsoft</c:v>
                 </c:pt>
                 <c:pt idx="4">
+                  <c:v>Anthropic</c:v>
+                </c:pt>
+                <c:pt idx="5">
                   <c:v>Alibaba</c:v>
                 </c:pt>
-                <c:pt idx="5">
+                <c:pt idx="6">
                   <c:v>Tencent</c:v>
                 </c:pt>
-                <c:pt idx="6">
+                <c:pt idx="7">
                   <c:v>xAI</c:v>
                 </c:pt>
-                <c:pt idx="7">
+                <c:pt idx="8">
                   <c:v>DeepSeek</c:v>
                 </c:pt>
               </c:strCache>
@@ -794,10 +799,10 @@
           </c:cat>
           <c:val>
             <c:numRef>
-              <c:f>Sheet1!$B$2:$B$9</c:f>
+              <c:f>Sheet1!$B$2:$B$10</c:f>
               <c:numCache>
                 <c:formatCode>General</c:formatCode>
-                <c:ptCount val="8"/>
+                <c:ptCount val="9"/>
                 <c:pt idx="0">
                   <c:v>0.586840240711296</c:v>
                 </c:pt>
@@ -811,15 +816,18 @@
                   <c:v>0.372288096107136</c:v>
                 </c:pt>
                 <c:pt idx="4">
+                  <c:v>0.31830324515136</c:v>
+                </c:pt>
+                <c:pt idx="5">
                   <c:v>0.259801314859008</c:v>
                 </c:pt>
-                <c:pt idx="5">
+                <c:pt idx="6">
                   <c:v>0.167354927293824</c:v>
                 </c:pt>
-                <c:pt idx="6">
+                <c:pt idx="7">
                   <c:v>0.125620159296096</c:v>
                 </c:pt>
-                <c:pt idx="7">
+                <c:pt idx="8">
                   <c:v>0.104360160022272</c:v>
                 </c:pt>
               </c:numCache>
@@ -913,6 +921,259 @@
               <c:strCache>
                 <c:ptCount val="1"/>
                 <c:pt idx="0">
+                  <c:v>우리 모델 annual QTokens</c:v>
+                </c:pt>
+              </c:strCache>
+            </c:strRef>
+          </c:tx>
+          <c:cat>
+            <c:strRef>
+              <c:f>Sheet1!$A$2:$A$10</c:f>
+              <c:strCache>
+                <c:ptCount val="9"/>
+                <c:pt idx="0">
+                  <c:v>OpenAI</c:v>
+                </c:pt>
+                <c:pt idx="1">
+                  <c:v>Google</c:v>
+                </c:pt>
+                <c:pt idx="2">
+                  <c:v>Meta</c:v>
+                </c:pt>
+                <c:pt idx="3">
+                  <c:v>Microsoft</c:v>
+                </c:pt>
+                <c:pt idx="4">
+                  <c:v>Anthropic</c:v>
+                </c:pt>
+                <c:pt idx="5">
+                  <c:v>Alibaba</c:v>
+                </c:pt>
+                <c:pt idx="6">
+                  <c:v>Tencent</c:v>
+                </c:pt>
+                <c:pt idx="7">
+                  <c:v>xAI</c:v>
+                </c:pt>
+                <c:pt idx="8">
+                  <c:v>DeepSeek</c:v>
+                </c:pt>
+              </c:strCache>
+            </c:strRef>
+          </c:cat>
+          <c:val>
+            <c:numRef>
+              <c:f>Sheet1!$B$2:$B$10</c:f>
+              <c:numCache>
+                <c:formatCode>General</c:formatCode>
+                <c:ptCount val="9"/>
+                <c:pt idx="0">
+                  <c:v>214.197</c:v>
+                </c:pt>
+                <c:pt idx="1">
+                  <c:v>195.323</c:v>
+                </c:pt>
+                <c:pt idx="2">
+                  <c:v>146.835</c:v>
+                </c:pt>
+                <c:pt idx="3">
+                  <c:v>135.885</c:v>
+                </c:pt>
+                <c:pt idx="4">
+                  <c:v>116.181</c:v>
+                </c:pt>
+                <c:pt idx="5">
+                  <c:v>94.827</c:v>
+                </c:pt>
+                <c:pt idx="6">
+                  <c:v>61.085</c:v>
+                </c:pt>
+                <c:pt idx="7">
+                  <c:v>45.851</c:v>
+                </c:pt>
+                <c:pt idx="8">
+                  <c:v>38.091</c:v>
+                </c:pt>
+              </c:numCache>
+            </c:numRef>
+          </c:val>
+        </c:ser>
+        <c:ser>
+          <c:idx val="1"/>
+          <c:order val="1"/>
+          <c:tx>
+            <c:strRef>
+              <c:f>Sheet1!$C$1</c:f>
+              <c:strCache>
+                <c:ptCount val="1"/>
+                <c:pt idx="0">
+                  <c:v>Benchmark reference annual QTokens</c:v>
+                </c:pt>
+              </c:strCache>
+            </c:strRef>
+          </c:tx>
+          <c:cat>
+            <c:strRef>
+              <c:f>Sheet1!$A$2:$A$10</c:f>
+              <c:strCache>
+                <c:ptCount val="9"/>
+                <c:pt idx="0">
+                  <c:v>OpenAI</c:v>
+                </c:pt>
+                <c:pt idx="1">
+                  <c:v>Google</c:v>
+                </c:pt>
+                <c:pt idx="2">
+                  <c:v>Meta</c:v>
+                </c:pt>
+                <c:pt idx="3">
+                  <c:v>Microsoft</c:v>
+                </c:pt>
+                <c:pt idx="4">
+                  <c:v>Anthropic</c:v>
+                </c:pt>
+                <c:pt idx="5">
+                  <c:v>Alibaba</c:v>
+                </c:pt>
+                <c:pt idx="6">
+                  <c:v>Tencent</c:v>
+                </c:pt>
+                <c:pt idx="7">
+                  <c:v>xAI</c:v>
+                </c:pt>
+                <c:pt idx="8">
+                  <c:v>DeepSeek</c:v>
+                </c:pt>
+              </c:strCache>
+            </c:strRef>
+          </c:cat>
+          <c:val>
+            <c:numRef>
+              <c:f>Sheet1!$C$2:$C$10</c:f>
+              <c:numCache>
+                <c:formatCode>General</c:formatCode>
+                <c:ptCount val="9"/>
+                <c:pt idx="0">
+                  <c:v>68.9</c:v>
+                </c:pt>
+                <c:pt idx="1">
+                  <c:v>56.678</c:v>
+                </c:pt>
+                <c:pt idx="2">
+                  <c:v>149.856</c:v>
+                </c:pt>
+                <c:pt idx="3">
+                  <c:v>50.263</c:v>
+                </c:pt>
+                <c:pt idx="4">
+                  <c:v>33.247</c:v>
+                </c:pt>
+                <c:pt idx="5">
+                  <c:v>11.103</c:v>
+                </c:pt>
+                <c:pt idx="6">
+                  <c:v>13.793</c:v>
+                </c:pt>
+                <c:pt idx="7">
+                  <c:v>14.113</c:v>
+                </c:pt>
+                <c:pt idx="8">
+                  <c:v>84.878</c:v>
+                </c:pt>
+              </c:numCache>
+            </c:numRef>
+          </c:val>
+        </c:ser>
+        <c:axId val="-2068027336"/>
+        <c:axId val="-2113994440"/>
+      </c:barChart>
+      <c:catAx>
+        <c:axId val="-2068027336"/>
+        <c:scaling>
+          <c:orientation val="minMax"/>
+        </c:scaling>
+        <c:delete val="0"/>
+        <c:axPos val="b"/>
+        <c:majorTickMark val="out"/>
+        <c:minorTickMark val="none"/>
+        <c:tickLblPos val="nextTo"/>
+        <c:txPr>
+          <a:bodyPr/>
+          <a:lstStyle/>
+          <a:p>
+            <a:pPr>
+              <a:defRPr sz="800"/>
+            </a:pPr>
+          </a:p>
+        </c:txPr>
+        <c:crossAx val="-2113994440"/>
+        <c:crosses val="autoZero"/>
+        <c:auto val="1"/>
+        <c:lblAlgn val="ctr"/>
+        <c:lblOffset val="100"/>
+        <c:noMultiLvlLbl val="0"/>
+      </c:catAx>
+      <c:valAx>
+        <c:axId val="-2113994440"/>
+        <c:scaling/>
+        <c:delete val="0"/>
+        <c:axPos val="l"/>
+        <c:majorGridlines/>
+        <c:majorTickMark val="out"/>
+        <c:minorTickMark val="none"/>
+        <c:tickLblPos val="nextTo"/>
+        <c:txPr>
+          <a:bodyPr/>
+          <a:lstStyle/>
+          <a:p>
+            <a:pPr>
+              <a:defRPr sz="800"/>
+            </a:pPr>
+          </a:p>
+        </c:txPr>
+        <c:crossAx val="-2068027336"/>
+        <c:crosses val="autoZero"/>
+      </c:valAx>
+    </c:plotArea>
+    <c:legend>
+      <c:legendPos val="b"/>
+    </c:legend>
+    <c:dispBlanksAs val="gap"/>
+  </c:chart>
+  <c:txPr>
+    <a:bodyPr/>
+    <a:lstStyle/>
+    <a:p>
+      <a:pPr>
+        <a:defRPr sz="1800"/>
+      </a:pPr>
+      <a:endParaRPr lang="en-US"/>
+    </a:p>
+  </c:txPr>
+  <c:externalData r:id="rId1">
+    <c:autoUpdate val="0"/>
+  </c:externalData>
+</c:chartSpace>
+</file>
+
+<file path=ppt/charts/chart6.xml><?xml version="1.0" encoding="utf-8"?>
+<c:chartSpace xmlns:c="http://schemas.openxmlformats.org/drawingml/2006/chart" xmlns:a="http://schemas.openxmlformats.org/drawingml/2006/main" xmlns:r="http://schemas.openxmlformats.org/officeDocument/2006/relationships">
+  <c:date1904 val="0"/>
+  <c:chart>
+    <c:autoTitleDeleted val="0"/>
+    <c:plotArea>
+      <c:barChart>
+        <c:barDir val="col"/>
+        <c:grouping val="clustered"/>
+        <c:ser>
+          <c:idx val="0"/>
+          <c:order val="0"/>
+          <c:tx>
+            <c:strRef>
+              <c:f>Sheet1!$B$1</c:f>
+              <c:strCache>
+                <c:ptCount val="1"/>
+                <c:pt idx="0">
                   <c:v>2026</c:v>
                 </c:pt>
               </c:strCache>
@@ -945,16 +1206,16 @@
                 <c:formatCode>General</c:formatCode>
                 <c:ptCount val="4"/>
                 <c:pt idx="0">
-                  <c:v>0.484</c:v>
+                  <c:v>0.479</c:v>
                 </c:pt>
                 <c:pt idx="1">
-                  <c:v>0.564</c:v>
+                  <c:v>0.559</c:v>
                 </c:pt>
                 <c:pt idx="2">
-                  <c:v>0.614</c:v>
+                  <c:v>0.609</c:v>
                 </c:pt>
                 <c:pt idx="3">
-                  <c:v>0.584</c:v>
+                  <c:v>0.579</c:v>
                 </c:pt>
               </c:numCache>
             </c:numRef>
@@ -1001,16 +1262,16 @@
                 <c:formatCode>General</c:formatCode>
                 <c:ptCount val="4"/>
                 <c:pt idx="0">
-                  <c:v>0.662</c:v>
+                  <c:v>0.659</c:v>
                 </c:pt>
                 <c:pt idx="1">
-                  <c:v>0.762</c:v>
+                  <c:v>0.759</c:v>
                 </c:pt>
                 <c:pt idx="2">
-                  <c:v>0.842</c:v>
+                  <c:v>0.839</c:v>
                 </c:pt>
                 <c:pt idx="3">
-                  <c:v>0.802</c:v>
+                  <c:v>0.799</c:v>
                 </c:pt>
               </c:numCache>
             </c:numRef>
@@ -4168,7 +4429,7 @@
               </a:defRPr>
             </a:pPr>
             <a:r>
-              <a:t>모델 보유 업체 기준으로 OpenAI, Google, Meta, Microsoft, xAI, DeepSeek, Alibaba, Tencent의 추론 capacity를 추정</a:t>
+              <a:t>모델 보유 업체 기준으로 OpenAI, Anthropic, Google, Meta, Microsoft, xAI, DeepSeek, Alibaba, Tencent의 추론 capacity를 추정</a:t>
             </a:r>
           </a:p>
         </p:txBody>
@@ -4234,7 +4495,7 @@
               </a:defRPr>
             </a:pPr>
             <a:r>
-              <a:t>2.55Q</a:t>
+              <a:t>2.87Q</a:t>
             </a:r>
           </a:p>
           <a:p>
@@ -4246,7 +4507,7 @@
               </a:defRPr>
             </a:pPr>
             <a:r>
-              <a:t>8개 상용 LLM owner 합산</a:t>
+              <a:t>9개 상용 LLM owner 합산</a:t>
             </a:r>
           </a:p>
         </p:txBody>
@@ -4312,7 +4573,7 @@
               </a:defRPr>
             </a:pPr>
             <a:r>
-              <a:t>20.1 GW</a:t>
+              <a:t>23.0 GW</a:t>
             </a:r>
           </a:p>
           <a:p>
@@ -4533,7 +4794,7 @@
               </a:defRPr>
             </a:pPr>
             <a:r>
-              <a:t>메모리 마케팅 시사점</a:t>
+              <a:t>모델 보유 업체 landscape</a:t>
             </a:r>
           </a:p>
         </p:txBody>
@@ -4568,7 +4829,7 @@
               </a:defRPr>
             </a:pPr>
             <a:r>
-              <a:t>토큰 capacity 성장은 allocation, qualification, attach-rate 영업 motion으로 전환된다.</a:t>
+              <a:t>Core row는 데이터센터 host가 아니라 상용 LLM owner다.</a:t>
             </a:r>
           </a:p>
         </p:txBody>
@@ -4581,8 +4842,8 @@
         </p:nvSpPr>
         <p:spPr>
           <a:xfrm>
-            <a:off x="731520" y="1325880"/>
-            <a:ext cx="5074920" cy="1078992"/>
+            <a:off x="731520" y="1234440"/>
+            <a:ext cx="3337560" cy="4297680"/>
           </a:xfrm>
           <a:prstGeom prst="rect">
             <a:avLst/>
@@ -4611,53 +4872,408 @@
           </a:fontRef>
         </p:style>
         <p:txBody>
-          <a:bodyPr rtlCol="0" anchor="ctr" lIns="146304" rIns="109728" tIns="109728"/>
-          <a:lstStyle/>
-          <a:p>
-            <a:pPr algn="ctr">
-              <a:defRPr sz="900">
+          <a:bodyPr rtlCol="0" anchor="ctr"/>
+          <a:lstStyle/>
+          <a:p>
+            <a:pPr algn="ctr"/>
+          </a:p>
+        </p:txBody>
+      </p:sp>
+      <p:sp>
+        <p:nvSpPr>
+          <p:cNvPr id="5" name="TextBox 4"/>
+          <p:cNvSpPr txBox="1"/>
+          <p:nvPr/>
+        </p:nvSpPr>
+        <p:spPr>
+          <a:xfrm>
+            <a:off x="896112" y="1444752"/>
+            <a:ext cx="2926080" cy="292608"/>
+          </a:xfrm>
+          <a:prstGeom prst="rect">
+            <a:avLst/>
+          </a:prstGeom>
+          <a:noFill/>
+        </p:spPr>
+        <p:txBody>
+          <a:bodyPr wrap="none" lIns="0" rIns="0" tIns="0" bIns="0">
+            <a:spAutoFit/>
+          </a:bodyPr>
+          <a:lstStyle/>
+          <a:p>
+            <a:pPr algn="l">
+              <a:defRPr sz="1300" b="1">
+                <a:solidFill>
+                  <a:srgbClr val="122037"/>
+                </a:solidFill>
+              </a:defRPr>
+            </a:pPr>
+            <a:r>
+              <a:t>미국 대형 플랫폼</a:t>
+            </a:r>
+          </a:p>
+        </p:txBody>
+      </p:sp>
+      <p:sp>
+        <p:nvSpPr>
+          <p:cNvPr id="6" name="TextBox 5"/>
+          <p:cNvSpPr txBox="1"/>
+          <p:nvPr/>
+        </p:nvSpPr>
+        <p:spPr>
+          <a:xfrm>
+            <a:off x="932688" y="1993392"/>
+            <a:ext cx="2834640" cy="237744"/>
+          </a:xfrm>
+          <a:prstGeom prst="rect">
+            <a:avLst/>
+          </a:prstGeom>
+          <a:noFill/>
+        </p:spPr>
+        <p:txBody>
+          <a:bodyPr wrap="none" lIns="0" rIns="0" tIns="0" bIns="0">
+            <a:spAutoFit/>
+          </a:bodyPr>
+          <a:lstStyle/>
+          <a:p>
+            <a:pPr algn="l">
+              <a:defRPr sz="1300" b="1">
+                <a:solidFill>
+                  <a:srgbClr val="1E293B"/>
+                </a:solidFill>
+              </a:defRPr>
+            </a:pPr>
+            <a:r>
+              <a:t>OpenAI</a:t>
+            </a:r>
+          </a:p>
+        </p:txBody>
+      </p:sp>
+      <p:sp>
+        <p:nvSpPr>
+          <p:cNvPr id="7" name="TextBox 6"/>
+          <p:cNvSpPr txBox="1"/>
+          <p:nvPr/>
+        </p:nvSpPr>
+        <p:spPr>
+          <a:xfrm>
+            <a:off x="932688" y="2267712"/>
+            <a:ext cx="2834640" cy="256032"/>
+          </a:xfrm>
+          <a:prstGeom prst="rect">
+            <a:avLst/>
+          </a:prstGeom>
+          <a:noFill/>
+        </p:spPr>
+        <p:txBody>
+          <a:bodyPr wrap="none" lIns="0" rIns="0" tIns="0" bIns="0">
+            <a:spAutoFit/>
+          </a:bodyPr>
+          <a:lstStyle/>
+          <a:p>
+            <a:pPr algn="l">
+              <a:defRPr sz="830" b="0">
                 <a:solidFill>
                   <a:srgbClr val="64748B"/>
                 </a:solidFill>
               </a:defRPr>
             </a:pPr>
             <a:r>
-              <a:t>HBM</a:t>
-            </a:r>
-          </a:p>
-          <a:p>
-            <a:pPr>
-              <a:defRPr sz="2000" b="1">
-                <a:solidFill>
-                  <a:srgbClr val="122037"/>
-                </a:solidFill>
-              </a:defRPr>
-            </a:pPr>
-          </a:p>
-          <a:p>
-            <a:pPr>
-              <a:defRPr sz="850">
+              <a:t>GPT / o-series / ChatGPT</a:t>
+            </a:r>
+          </a:p>
+        </p:txBody>
+      </p:sp>
+      <p:sp>
+        <p:nvSpPr>
+          <p:cNvPr id="8" name="TextBox 7"/>
+          <p:cNvSpPr txBox="1"/>
+          <p:nvPr/>
+        </p:nvSpPr>
+        <p:spPr>
+          <a:xfrm>
+            <a:off x="932688" y="2743200"/>
+            <a:ext cx="2834640" cy="237744"/>
+          </a:xfrm>
+          <a:prstGeom prst="rect">
+            <a:avLst/>
+          </a:prstGeom>
+          <a:noFill/>
+        </p:spPr>
+        <p:txBody>
+          <a:bodyPr wrap="none" lIns="0" rIns="0" tIns="0" bIns="0">
+            <a:spAutoFit/>
+          </a:bodyPr>
+          <a:lstStyle/>
+          <a:p>
+            <a:pPr algn="l">
+              <a:defRPr sz="1300" b="1">
+                <a:solidFill>
+                  <a:srgbClr val="1E293B"/>
+                </a:solidFill>
+              </a:defRPr>
+            </a:pPr>
+            <a:r>
+              <a:t>Anthropic</a:t>
+            </a:r>
+          </a:p>
+        </p:txBody>
+      </p:sp>
+      <p:sp>
+        <p:nvSpPr>
+          <p:cNvPr id="9" name="TextBox 8"/>
+          <p:cNvSpPr txBox="1"/>
+          <p:nvPr/>
+        </p:nvSpPr>
+        <p:spPr>
+          <a:xfrm>
+            <a:off x="932688" y="3017520"/>
+            <a:ext cx="2834640" cy="256032"/>
+          </a:xfrm>
+          <a:prstGeom prst="rect">
+            <a:avLst/>
+          </a:prstGeom>
+          <a:noFill/>
+        </p:spPr>
+        <p:txBody>
+          <a:bodyPr wrap="none" lIns="0" rIns="0" tIns="0" bIns="0">
+            <a:spAutoFit/>
+          </a:bodyPr>
+          <a:lstStyle/>
+          <a:p>
+            <a:pPr algn="l">
+              <a:defRPr sz="830" b="0">
                 <a:solidFill>
                   <a:srgbClr val="64748B"/>
                 </a:solidFill>
               </a:defRPr>
             </a:pPr>
             <a:r>
-              <a:t>OpenAI/Google/Meta/xAI ramp → LTA, HBM4 roadmap lock-in, second-source qualification</a:t>
-            </a:r>
-          </a:p>
-        </p:txBody>
-      </p:sp>
-      <p:sp>
-        <p:nvSpPr>
-          <p:cNvPr id="5" name="Rectangle 4"/>
+              <a:t>Claude Opus / Sonnet / Haiku</a:t>
+            </a:r>
+          </a:p>
+        </p:txBody>
+      </p:sp>
+      <p:sp>
+        <p:nvSpPr>
+          <p:cNvPr id="10" name="TextBox 9"/>
+          <p:cNvSpPr txBox="1"/>
+          <p:nvPr/>
+        </p:nvSpPr>
+        <p:spPr>
+          <a:xfrm>
+            <a:off x="932688" y="3493008"/>
+            <a:ext cx="2834640" cy="237744"/>
+          </a:xfrm>
+          <a:prstGeom prst="rect">
+            <a:avLst/>
+          </a:prstGeom>
+          <a:noFill/>
+        </p:spPr>
+        <p:txBody>
+          <a:bodyPr wrap="none" lIns="0" rIns="0" tIns="0" bIns="0">
+            <a:spAutoFit/>
+          </a:bodyPr>
+          <a:lstStyle/>
+          <a:p>
+            <a:pPr algn="l">
+              <a:defRPr sz="1300" b="1">
+                <a:solidFill>
+                  <a:srgbClr val="1E293B"/>
+                </a:solidFill>
+              </a:defRPr>
+            </a:pPr>
+            <a:r>
+              <a:t>Google</a:t>
+            </a:r>
+          </a:p>
+        </p:txBody>
+      </p:sp>
+      <p:sp>
+        <p:nvSpPr>
+          <p:cNvPr id="11" name="TextBox 10"/>
+          <p:cNvSpPr txBox="1"/>
+          <p:nvPr/>
+        </p:nvSpPr>
+        <p:spPr>
+          <a:xfrm>
+            <a:off x="932688" y="3767328"/>
+            <a:ext cx="2834640" cy="256032"/>
+          </a:xfrm>
+          <a:prstGeom prst="rect">
+            <a:avLst/>
+          </a:prstGeom>
+          <a:noFill/>
+        </p:spPr>
+        <p:txBody>
+          <a:bodyPr wrap="none" lIns="0" rIns="0" tIns="0" bIns="0">
+            <a:spAutoFit/>
+          </a:bodyPr>
+          <a:lstStyle/>
+          <a:p>
+            <a:pPr algn="l">
+              <a:defRPr sz="830" b="0">
+                <a:solidFill>
+                  <a:srgbClr val="64748B"/>
+                </a:solidFill>
+              </a:defRPr>
+            </a:pPr>
+            <a:r>
+              <a:t>Gemini / Gemma</a:t>
+            </a:r>
+          </a:p>
+        </p:txBody>
+      </p:sp>
+      <p:sp>
+        <p:nvSpPr>
+          <p:cNvPr id="12" name="TextBox 11"/>
+          <p:cNvSpPr txBox="1"/>
+          <p:nvPr/>
+        </p:nvSpPr>
+        <p:spPr>
+          <a:xfrm>
+            <a:off x="932688" y="4242816"/>
+            <a:ext cx="2834640" cy="237744"/>
+          </a:xfrm>
+          <a:prstGeom prst="rect">
+            <a:avLst/>
+          </a:prstGeom>
+          <a:noFill/>
+        </p:spPr>
+        <p:txBody>
+          <a:bodyPr wrap="none" lIns="0" rIns="0" tIns="0" bIns="0">
+            <a:spAutoFit/>
+          </a:bodyPr>
+          <a:lstStyle/>
+          <a:p>
+            <a:pPr algn="l">
+              <a:defRPr sz="1300" b="1">
+                <a:solidFill>
+                  <a:srgbClr val="1E293B"/>
+                </a:solidFill>
+              </a:defRPr>
+            </a:pPr>
+            <a:r>
+              <a:t>Meta</a:t>
+            </a:r>
+          </a:p>
+        </p:txBody>
+      </p:sp>
+      <p:sp>
+        <p:nvSpPr>
+          <p:cNvPr id="13" name="TextBox 12"/>
+          <p:cNvSpPr txBox="1"/>
+          <p:nvPr/>
+        </p:nvSpPr>
+        <p:spPr>
+          <a:xfrm>
+            <a:off x="932688" y="4517136"/>
+            <a:ext cx="2834640" cy="256032"/>
+          </a:xfrm>
+          <a:prstGeom prst="rect">
+            <a:avLst/>
+          </a:prstGeom>
+          <a:noFill/>
+        </p:spPr>
+        <p:txBody>
+          <a:bodyPr wrap="none" lIns="0" rIns="0" tIns="0" bIns="0">
+            <a:spAutoFit/>
+          </a:bodyPr>
+          <a:lstStyle/>
+          <a:p>
+            <a:pPr algn="l">
+              <a:defRPr sz="830" b="0">
+                <a:solidFill>
+                  <a:srgbClr val="64748B"/>
+                </a:solidFill>
+              </a:defRPr>
+            </a:pPr>
+            <a:r>
+              <a:t>Llama / Meta AI</a:t>
+            </a:r>
+          </a:p>
+        </p:txBody>
+      </p:sp>
+      <p:sp>
+        <p:nvSpPr>
+          <p:cNvPr id="14" name="TextBox 13"/>
+          <p:cNvSpPr txBox="1"/>
+          <p:nvPr/>
+        </p:nvSpPr>
+        <p:spPr>
+          <a:xfrm>
+            <a:off x="932688" y="4992624"/>
+            <a:ext cx="2834640" cy="237744"/>
+          </a:xfrm>
+          <a:prstGeom prst="rect">
+            <a:avLst/>
+          </a:prstGeom>
+          <a:noFill/>
+        </p:spPr>
+        <p:txBody>
+          <a:bodyPr wrap="none" lIns="0" rIns="0" tIns="0" bIns="0">
+            <a:spAutoFit/>
+          </a:bodyPr>
+          <a:lstStyle/>
+          <a:p>
+            <a:pPr algn="l">
+              <a:defRPr sz="1300" b="1">
+                <a:solidFill>
+                  <a:srgbClr val="1E293B"/>
+                </a:solidFill>
+              </a:defRPr>
+            </a:pPr>
+            <a:r>
+              <a:t>Microsoft</a:t>
+            </a:r>
+          </a:p>
+        </p:txBody>
+      </p:sp>
+      <p:sp>
+        <p:nvSpPr>
+          <p:cNvPr id="15" name="TextBox 14"/>
+          <p:cNvSpPr txBox="1"/>
+          <p:nvPr/>
+        </p:nvSpPr>
+        <p:spPr>
+          <a:xfrm>
+            <a:off x="932688" y="5266944"/>
+            <a:ext cx="2834640" cy="256032"/>
+          </a:xfrm>
+          <a:prstGeom prst="rect">
+            <a:avLst/>
+          </a:prstGeom>
+          <a:noFill/>
+        </p:spPr>
+        <p:txBody>
+          <a:bodyPr wrap="none" lIns="0" rIns="0" tIns="0" bIns="0">
+            <a:spAutoFit/>
+          </a:bodyPr>
+          <a:lstStyle/>
+          <a:p>
+            <a:pPr algn="l">
+              <a:defRPr sz="830" b="0">
+                <a:solidFill>
+                  <a:srgbClr val="64748B"/>
+                </a:solidFill>
+              </a:defRPr>
+            </a:pPr>
+            <a:r>
+              <a:t>Phi / MAI / Copilot model mix</a:t>
+            </a:r>
+          </a:p>
+        </p:txBody>
+      </p:sp>
+      <p:sp>
+        <p:nvSpPr>
+          <p:cNvPr id="16" name="Rectangle 15"/>
           <p:cNvSpPr/>
           <p:nvPr/>
         </p:nvSpPr>
         <p:spPr>
           <a:xfrm>
-            <a:off x="6263640" y="1325880"/>
-            <a:ext cx="5074920" cy="1078992"/>
+            <a:off x="4526280" y="1234440"/>
+            <a:ext cx="3337560" cy="4297680"/>
           </a:xfrm>
           <a:prstGeom prst="rect">
             <a:avLst/>
@@ -4686,53 +5302,128 @@
           </a:fontRef>
         </p:style>
         <p:txBody>
-          <a:bodyPr rtlCol="0" anchor="ctr" lIns="146304" rIns="109728" tIns="109728"/>
-          <a:lstStyle/>
-          <a:p>
-            <a:pPr algn="ctr">
-              <a:defRPr sz="900">
+          <a:bodyPr rtlCol="0" anchor="ctr"/>
+          <a:lstStyle/>
+          <a:p>
+            <a:pPr algn="ctr"/>
+          </a:p>
+        </p:txBody>
+      </p:sp>
+      <p:sp>
+        <p:nvSpPr>
+          <p:cNvPr id="17" name="TextBox 16"/>
+          <p:cNvSpPr txBox="1"/>
+          <p:nvPr/>
+        </p:nvSpPr>
+        <p:spPr>
+          <a:xfrm>
+            <a:off x="4690872" y="1444752"/>
+            <a:ext cx="2926080" cy="292608"/>
+          </a:xfrm>
+          <a:prstGeom prst="rect">
+            <a:avLst/>
+          </a:prstGeom>
+          <a:noFill/>
+        </p:spPr>
+        <p:txBody>
+          <a:bodyPr wrap="none" lIns="0" rIns="0" tIns="0" bIns="0">
+            <a:spAutoFit/>
+          </a:bodyPr>
+          <a:lstStyle/>
+          <a:p>
+            <a:pPr algn="l">
+              <a:defRPr sz="1300" b="1">
+                <a:solidFill>
+                  <a:srgbClr val="122037"/>
+                </a:solidFill>
+              </a:defRPr>
+            </a:pPr>
+            <a:r>
+              <a:t>미국 challenger</a:t>
+            </a:r>
+          </a:p>
+        </p:txBody>
+      </p:sp>
+      <p:sp>
+        <p:nvSpPr>
+          <p:cNvPr id="18" name="TextBox 17"/>
+          <p:cNvSpPr txBox="1"/>
+          <p:nvPr/>
+        </p:nvSpPr>
+        <p:spPr>
+          <a:xfrm>
+            <a:off x="4727448" y="1993392"/>
+            <a:ext cx="2834640" cy="237744"/>
+          </a:xfrm>
+          <a:prstGeom prst="rect">
+            <a:avLst/>
+          </a:prstGeom>
+          <a:noFill/>
+        </p:spPr>
+        <p:txBody>
+          <a:bodyPr wrap="none" lIns="0" rIns="0" tIns="0" bIns="0">
+            <a:spAutoFit/>
+          </a:bodyPr>
+          <a:lstStyle/>
+          <a:p>
+            <a:pPr algn="l">
+              <a:defRPr sz="1300" b="1">
+                <a:solidFill>
+                  <a:srgbClr val="1E293B"/>
+                </a:solidFill>
+              </a:defRPr>
+            </a:pPr>
+            <a:r>
+              <a:t>xAI</a:t>
+            </a:r>
+          </a:p>
+        </p:txBody>
+      </p:sp>
+      <p:sp>
+        <p:nvSpPr>
+          <p:cNvPr id="19" name="TextBox 18"/>
+          <p:cNvSpPr txBox="1"/>
+          <p:nvPr/>
+        </p:nvSpPr>
+        <p:spPr>
+          <a:xfrm>
+            <a:off x="4727448" y="2267712"/>
+            <a:ext cx="2834640" cy="256032"/>
+          </a:xfrm>
+          <a:prstGeom prst="rect">
+            <a:avLst/>
+          </a:prstGeom>
+          <a:noFill/>
+        </p:spPr>
+        <p:txBody>
+          <a:bodyPr wrap="none" lIns="0" rIns="0" tIns="0" bIns="0">
+            <a:spAutoFit/>
+          </a:bodyPr>
+          <a:lstStyle/>
+          <a:p>
+            <a:pPr algn="l">
+              <a:defRPr sz="830" b="0">
                 <a:solidFill>
                   <a:srgbClr val="64748B"/>
                 </a:solidFill>
               </a:defRPr>
             </a:pPr>
             <a:r>
-              <a:t>DDR5 / MRDIMM</a:t>
-            </a:r>
-          </a:p>
-          <a:p>
-            <a:pPr>
-              <a:defRPr sz="2000" b="1">
-                <a:solidFill>
-                  <a:srgbClr val="122037"/>
-                </a:solidFill>
-              </a:defRPr>
-            </a:pPr>
-          </a:p>
-          <a:p>
-            <a:pPr>
-              <a:defRPr sz="850">
-                <a:solidFill>
-                  <a:srgbClr val="64748B"/>
-                </a:solidFill>
-              </a:defRPr>
-            </a:pPr>
-            <a:r>
-              <a:t>추론 fleet 확대 → CPU-side memory density와 bandwidth attach story</a:t>
-            </a:r>
-          </a:p>
-        </p:txBody>
-      </p:sp>
-      <p:sp>
-        <p:nvSpPr>
-          <p:cNvPr id="6" name="Rectangle 5"/>
+              <a:t>Grok</a:t>
+            </a:r>
+          </a:p>
+        </p:txBody>
+      </p:sp>
+      <p:sp>
+        <p:nvSpPr>
+          <p:cNvPr id="20" name="Rectangle 19"/>
           <p:cNvSpPr/>
           <p:nvPr/>
         </p:nvSpPr>
         <p:spPr>
           <a:xfrm>
-            <a:off x="731520" y="2926080"/>
-            <a:ext cx="5074920" cy="1078992"/>
+            <a:off x="8321040" y="1234440"/>
+            <a:ext cx="3337560" cy="4297680"/>
           </a:xfrm>
           <a:prstGeom prst="rect">
             <a:avLst/>
@@ -4761,128 +5452,23 @@
           </a:fontRef>
         </p:style>
         <p:txBody>
-          <a:bodyPr rtlCol="0" anchor="ctr" lIns="146304" rIns="109728" tIns="109728"/>
-          <a:lstStyle/>
-          <a:p>
-            <a:pPr algn="ctr">
-              <a:defRPr sz="900">
-                <a:solidFill>
-                  <a:srgbClr val="64748B"/>
-                </a:solidFill>
-              </a:defRPr>
-            </a:pPr>
-            <a:r>
-              <a:t>Enterprise SSD / QLC</a:t>
-            </a:r>
-          </a:p>
-          <a:p>
-            <a:pPr>
-              <a:defRPr sz="2000" b="1">
-                <a:solidFill>
-                  <a:srgbClr val="122037"/>
-                </a:solidFill>
-              </a:defRPr>
-            </a:pPr>
-          </a:p>
-          <a:p>
-            <a:pPr>
-              <a:defRPr sz="850">
-                <a:solidFill>
-                  <a:srgbClr val="64748B"/>
-                </a:solidFill>
-              </a:defRPr>
-            </a:pPr>
-            <a:r>
-              <a:t>RAG, checkpointing, vector retrieval → TCO, endurance, retrieval latency</a:t>
-            </a:r>
-          </a:p>
-        </p:txBody>
-      </p:sp>
-      <p:sp>
-        <p:nvSpPr>
-          <p:cNvPr id="7" name="Rectangle 6"/>
-          <p:cNvSpPr/>
-          <p:nvPr/>
-        </p:nvSpPr>
-        <p:spPr>
-          <a:xfrm>
-            <a:off x="6263640" y="2926080"/>
-            <a:ext cx="5074920" cy="1078992"/>
-          </a:xfrm>
-          <a:prstGeom prst="rect">
-            <a:avLst/>
-          </a:prstGeom>
-          <a:solidFill>
-            <a:srgbClr val="F0F4F8"/>
-          </a:solidFill>
-          <a:ln>
-            <a:solidFill>
-              <a:srgbClr val="DAE2EC"/>
-            </a:solidFill>
-          </a:ln>
-        </p:spPr>
-        <p:style>
-          <a:lnRef idx="1">
-            <a:schemeClr val="accent1"/>
-          </a:lnRef>
-          <a:fillRef idx="3">
-            <a:schemeClr val="accent1"/>
-          </a:fillRef>
-          <a:effectRef idx="2">
-            <a:schemeClr val="accent1"/>
-          </a:effectRef>
-          <a:fontRef idx="minor">
-            <a:schemeClr val="lt1"/>
-          </a:fontRef>
-        </p:style>
-        <p:txBody>
-          <a:bodyPr rtlCol="0" anchor="ctr" lIns="146304" rIns="109728" tIns="109728"/>
-          <a:lstStyle/>
-          <a:p>
-            <a:pPr algn="ctr">
-              <a:defRPr sz="900">
-                <a:solidFill>
-                  <a:srgbClr val="64748B"/>
-                </a:solidFill>
-              </a:defRPr>
-            </a:pPr>
-            <a:r>
-              <a:t>CXL</a:t>
-            </a:r>
-          </a:p>
-          <a:p>
-            <a:pPr>
-              <a:defRPr sz="2000" b="1">
-                <a:solidFill>
-                  <a:srgbClr val="122037"/>
-                </a:solidFill>
-              </a:defRPr>
-            </a:pPr>
-          </a:p>
-          <a:p>
-            <a:pPr>
-              <a:defRPr sz="850">
-                <a:solidFill>
-                  <a:srgbClr val="64748B"/>
-                </a:solidFill>
-              </a:defRPr>
-            </a:pPr>
-            <a:r>
-              <a:t>고가동률 추론 cluster → memory expansion과 utilization recovery</a:t>
-            </a:r>
-          </a:p>
-        </p:txBody>
-      </p:sp>
-      <p:sp>
-        <p:nvSpPr>
-          <p:cNvPr id="8" name="TextBox 7"/>
+          <a:bodyPr rtlCol="0" anchor="ctr"/>
+          <a:lstStyle/>
+          <a:p>
+            <a:pPr algn="ctr"/>
+          </a:p>
+        </p:txBody>
+      </p:sp>
+      <p:sp>
+        <p:nvSpPr>
+          <p:cNvPr id="21" name="TextBox 20"/>
           <p:cNvSpPr txBox="1"/>
           <p:nvPr/>
         </p:nvSpPr>
         <p:spPr>
           <a:xfrm>
-            <a:off x="777240" y="4983480"/>
-            <a:ext cx="10698480" cy="502920"/>
+            <a:off x="8485632" y="1444752"/>
+            <a:ext cx="2926080" cy="292608"/>
           </a:xfrm>
           <a:prstGeom prst="rect">
             <a:avLst/>
@@ -4903,14 +5489,224 @@
               </a:defRPr>
             </a:pPr>
             <a:r>
-              <a:t>권장 sales motion: model owner별 account brief, 제품별 proof pack, scenario envelope에 연결된 pricing/mix 논리.</a:t>
-            </a:r>
-          </a:p>
-        </p:txBody>
-      </p:sp>
-      <p:sp>
-        <p:nvSpPr>
-          <p:cNvPr id="9" name="TextBox 8"/>
+              <a:t>중국 model owner</a:t>
+            </a:r>
+          </a:p>
+        </p:txBody>
+      </p:sp>
+      <p:sp>
+        <p:nvSpPr>
+          <p:cNvPr id="22" name="TextBox 21"/>
+          <p:cNvSpPr txBox="1"/>
+          <p:nvPr/>
+        </p:nvSpPr>
+        <p:spPr>
+          <a:xfrm>
+            <a:off x="8522208" y="1993392"/>
+            <a:ext cx="2834640" cy="237744"/>
+          </a:xfrm>
+          <a:prstGeom prst="rect">
+            <a:avLst/>
+          </a:prstGeom>
+          <a:noFill/>
+        </p:spPr>
+        <p:txBody>
+          <a:bodyPr wrap="none" lIns="0" rIns="0" tIns="0" bIns="0">
+            <a:spAutoFit/>
+          </a:bodyPr>
+          <a:lstStyle/>
+          <a:p>
+            <a:pPr algn="l">
+              <a:defRPr sz="1300" b="1">
+                <a:solidFill>
+                  <a:srgbClr val="1E293B"/>
+                </a:solidFill>
+              </a:defRPr>
+            </a:pPr>
+            <a:r>
+              <a:t>DeepSeek</a:t>
+            </a:r>
+          </a:p>
+        </p:txBody>
+      </p:sp>
+      <p:sp>
+        <p:nvSpPr>
+          <p:cNvPr id="23" name="TextBox 22"/>
+          <p:cNvSpPr txBox="1"/>
+          <p:nvPr/>
+        </p:nvSpPr>
+        <p:spPr>
+          <a:xfrm>
+            <a:off x="8522208" y="2267712"/>
+            <a:ext cx="2834640" cy="256032"/>
+          </a:xfrm>
+          <a:prstGeom prst="rect">
+            <a:avLst/>
+          </a:prstGeom>
+          <a:noFill/>
+        </p:spPr>
+        <p:txBody>
+          <a:bodyPr wrap="none" lIns="0" rIns="0" tIns="0" bIns="0">
+            <a:spAutoFit/>
+          </a:bodyPr>
+          <a:lstStyle/>
+          <a:p>
+            <a:pPr algn="l">
+              <a:defRPr sz="830" b="0">
+                <a:solidFill>
+                  <a:srgbClr val="64748B"/>
+                </a:solidFill>
+              </a:defRPr>
+            </a:pPr>
+            <a:r>
+              <a:t>DeepSeek-V3 / R1</a:t>
+            </a:r>
+          </a:p>
+        </p:txBody>
+      </p:sp>
+      <p:sp>
+        <p:nvSpPr>
+          <p:cNvPr id="24" name="TextBox 23"/>
+          <p:cNvSpPr txBox="1"/>
+          <p:nvPr/>
+        </p:nvSpPr>
+        <p:spPr>
+          <a:xfrm>
+            <a:off x="8522208" y="2743200"/>
+            <a:ext cx="2834640" cy="237744"/>
+          </a:xfrm>
+          <a:prstGeom prst="rect">
+            <a:avLst/>
+          </a:prstGeom>
+          <a:noFill/>
+        </p:spPr>
+        <p:txBody>
+          <a:bodyPr wrap="none" lIns="0" rIns="0" tIns="0" bIns="0">
+            <a:spAutoFit/>
+          </a:bodyPr>
+          <a:lstStyle/>
+          <a:p>
+            <a:pPr algn="l">
+              <a:defRPr sz="1300" b="1">
+                <a:solidFill>
+                  <a:srgbClr val="1E293B"/>
+                </a:solidFill>
+              </a:defRPr>
+            </a:pPr>
+            <a:r>
+              <a:t>Alibaba</a:t>
+            </a:r>
+          </a:p>
+        </p:txBody>
+      </p:sp>
+      <p:sp>
+        <p:nvSpPr>
+          <p:cNvPr id="25" name="TextBox 24"/>
+          <p:cNvSpPr txBox="1"/>
+          <p:nvPr/>
+        </p:nvSpPr>
+        <p:spPr>
+          <a:xfrm>
+            <a:off x="8522208" y="3017520"/>
+            <a:ext cx="2834640" cy="256032"/>
+          </a:xfrm>
+          <a:prstGeom prst="rect">
+            <a:avLst/>
+          </a:prstGeom>
+          <a:noFill/>
+        </p:spPr>
+        <p:txBody>
+          <a:bodyPr wrap="none" lIns="0" rIns="0" tIns="0" bIns="0">
+            <a:spAutoFit/>
+          </a:bodyPr>
+          <a:lstStyle/>
+          <a:p>
+            <a:pPr algn="l">
+              <a:defRPr sz="830" b="0">
+                <a:solidFill>
+                  <a:srgbClr val="64748B"/>
+                </a:solidFill>
+              </a:defRPr>
+            </a:pPr>
+            <a:r>
+              <a:t>Qwen / Qwen3</a:t>
+            </a:r>
+          </a:p>
+        </p:txBody>
+      </p:sp>
+      <p:sp>
+        <p:nvSpPr>
+          <p:cNvPr id="26" name="TextBox 25"/>
+          <p:cNvSpPr txBox="1"/>
+          <p:nvPr/>
+        </p:nvSpPr>
+        <p:spPr>
+          <a:xfrm>
+            <a:off x="8522208" y="3493008"/>
+            <a:ext cx="2834640" cy="237744"/>
+          </a:xfrm>
+          <a:prstGeom prst="rect">
+            <a:avLst/>
+          </a:prstGeom>
+          <a:noFill/>
+        </p:spPr>
+        <p:txBody>
+          <a:bodyPr wrap="none" lIns="0" rIns="0" tIns="0" bIns="0">
+            <a:spAutoFit/>
+          </a:bodyPr>
+          <a:lstStyle/>
+          <a:p>
+            <a:pPr algn="l">
+              <a:defRPr sz="1300" b="1">
+                <a:solidFill>
+                  <a:srgbClr val="1E293B"/>
+                </a:solidFill>
+              </a:defRPr>
+            </a:pPr>
+            <a:r>
+              <a:t>Tencent</a:t>
+            </a:r>
+          </a:p>
+        </p:txBody>
+      </p:sp>
+      <p:sp>
+        <p:nvSpPr>
+          <p:cNvPr id="27" name="TextBox 26"/>
+          <p:cNvSpPr txBox="1"/>
+          <p:nvPr/>
+        </p:nvSpPr>
+        <p:spPr>
+          <a:xfrm>
+            <a:off x="8522208" y="3767328"/>
+            <a:ext cx="2834640" cy="256032"/>
+          </a:xfrm>
+          <a:prstGeom prst="rect">
+            <a:avLst/>
+          </a:prstGeom>
+          <a:noFill/>
+        </p:spPr>
+        <p:txBody>
+          <a:bodyPr wrap="none" lIns="0" rIns="0" tIns="0" bIns="0">
+            <a:spAutoFit/>
+          </a:bodyPr>
+          <a:lstStyle/>
+          <a:p>
+            <a:pPr algn="l">
+              <a:defRPr sz="830" b="0">
+                <a:solidFill>
+                  <a:srgbClr val="64748B"/>
+                </a:solidFill>
+              </a:defRPr>
+            </a:pPr>
+            <a:r>
+              <a:t>Hunyuan / Hy3 / Yuanbao</a:t>
+            </a:r>
+          </a:p>
+        </p:txBody>
+      </p:sp>
+      <p:sp>
+        <p:nvSpPr>
+          <p:cNvPr id="28" name="TextBox 27"/>
           <p:cNvSpPr txBox="1"/>
           <p:nvPr/>
         </p:nvSpPr>
@@ -4999,7 +5795,7 @@
               </a:defRPr>
             </a:pPr>
             <a:r>
-              <a:t>근거 신뢰도 감사</a:t>
+              <a:t>메모리 마케팅 시사점</a:t>
             </a:r>
           </a:p>
         </p:txBody>
@@ -5034,21 +5830,321 @@
               </a:defRPr>
             </a:pPr>
             <a:r>
-              <a:t>가장 강한 근거는 모델 크기와 발표 capacity이며, 가장 약한 부분은 active serving utilization이다.</a:t>
-            </a:r>
-          </a:p>
-        </p:txBody>
-      </p:sp>
-      <p:sp>
-        <p:nvSpPr>
-          <p:cNvPr id="4" name="TextBox 3"/>
+              <a:t>토큰 capacity 성장은 allocation, qualification, attach-rate 영업 motion으로 전환된다.</a:t>
+            </a:r>
+          </a:p>
+        </p:txBody>
+      </p:sp>
+      <p:sp>
+        <p:nvSpPr>
+          <p:cNvPr id="4" name="Rectangle 3"/>
+          <p:cNvSpPr/>
+          <p:nvPr/>
+        </p:nvSpPr>
+        <p:spPr>
+          <a:xfrm>
+            <a:off x="731520" y="1325880"/>
+            <a:ext cx="5074920" cy="1078992"/>
+          </a:xfrm>
+          <a:prstGeom prst="rect">
+            <a:avLst/>
+          </a:prstGeom>
+          <a:solidFill>
+            <a:srgbClr val="EBF2FF"/>
+          </a:solidFill>
+          <a:ln>
+            <a:solidFill>
+              <a:srgbClr val="DAE2EC"/>
+            </a:solidFill>
+          </a:ln>
+        </p:spPr>
+        <p:style>
+          <a:lnRef idx="1">
+            <a:schemeClr val="accent1"/>
+          </a:lnRef>
+          <a:fillRef idx="3">
+            <a:schemeClr val="accent1"/>
+          </a:fillRef>
+          <a:effectRef idx="2">
+            <a:schemeClr val="accent1"/>
+          </a:effectRef>
+          <a:fontRef idx="minor">
+            <a:schemeClr val="lt1"/>
+          </a:fontRef>
+        </p:style>
+        <p:txBody>
+          <a:bodyPr rtlCol="0" anchor="ctr" lIns="146304" rIns="109728" tIns="109728"/>
+          <a:lstStyle/>
+          <a:p>
+            <a:pPr algn="ctr">
+              <a:defRPr sz="900">
+                <a:solidFill>
+                  <a:srgbClr val="64748B"/>
+                </a:solidFill>
+              </a:defRPr>
+            </a:pPr>
+            <a:r>
+              <a:t>HBM</a:t>
+            </a:r>
+          </a:p>
+          <a:p>
+            <a:pPr>
+              <a:defRPr sz="2000" b="1">
+                <a:solidFill>
+                  <a:srgbClr val="122037"/>
+                </a:solidFill>
+              </a:defRPr>
+            </a:pPr>
+          </a:p>
+          <a:p>
+            <a:pPr>
+              <a:defRPr sz="850">
+                <a:solidFill>
+                  <a:srgbClr val="64748B"/>
+                </a:solidFill>
+              </a:defRPr>
+            </a:pPr>
+            <a:r>
+              <a:t>OpenAI/Google/Meta/xAI ramp → LTA, HBM4 roadmap lock-in, second-source qualification</a:t>
+            </a:r>
+          </a:p>
+        </p:txBody>
+      </p:sp>
+      <p:sp>
+        <p:nvSpPr>
+          <p:cNvPr id="5" name="Rectangle 4"/>
+          <p:cNvSpPr/>
+          <p:nvPr/>
+        </p:nvSpPr>
+        <p:spPr>
+          <a:xfrm>
+            <a:off x="6263640" y="1325880"/>
+            <a:ext cx="5074920" cy="1078992"/>
+          </a:xfrm>
+          <a:prstGeom prst="rect">
+            <a:avLst/>
+          </a:prstGeom>
+          <a:solidFill>
+            <a:srgbClr val="E8F8F0"/>
+          </a:solidFill>
+          <a:ln>
+            <a:solidFill>
+              <a:srgbClr val="DAE2EC"/>
+            </a:solidFill>
+          </a:ln>
+        </p:spPr>
+        <p:style>
+          <a:lnRef idx="1">
+            <a:schemeClr val="accent1"/>
+          </a:lnRef>
+          <a:fillRef idx="3">
+            <a:schemeClr val="accent1"/>
+          </a:fillRef>
+          <a:effectRef idx="2">
+            <a:schemeClr val="accent1"/>
+          </a:effectRef>
+          <a:fontRef idx="minor">
+            <a:schemeClr val="lt1"/>
+          </a:fontRef>
+        </p:style>
+        <p:txBody>
+          <a:bodyPr rtlCol="0" anchor="ctr" lIns="146304" rIns="109728" tIns="109728"/>
+          <a:lstStyle/>
+          <a:p>
+            <a:pPr algn="ctr">
+              <a:defRPr sz="900">
+                <a:solidFill>
+                  <a:srgbClr val="64748B"/>
+                </a:solidFill>
+              </a:defRPr>
+            </a:pPr>
+            <a:r>
+              <a:t>DDR5 / MRDIMM</a:t>
+            </a:r>
+          </a:p>
+          <a:p>
+            <a:pPr>
+              <a:defRPr sz="2000" b="1">
+                <a:solidFill>
+                  <a:srgbClr val="122037"/>
+                </a:solidFill>
+              </a:defRPr>
+            </a:pPr>
+          </a:p>
+          <a:p>
+            <a:pPr>
+              <a:defRPr sz="850">
+                <a:solidFill>
+                  <a:srgbClr val="64748B"/>
+                </a:solidFill>
+              </a:defRPr>
+            </a:pPr>
+            <a:r>
+              <a:t>추론 fleet 확대 → CPU-side memory density와 bandwidth attach story</a:t>
+            </a:r>
+          </a:p>
+        </p:txBody>
+      </p:sp>
+      <p:sp>
+        <p:nvSpPr>
+          <p:cNvPr id="6" name="Rectangle 5"/>
+          <p:cNvSpPr/>
+          <p:nvPr/>
+        </p:nvSpPr>
+        <p:spPr>
+          <a:xfrm>
+            <a:off x="731520" y="2926080"/>
+            <a:ext cx="5074920" cy="1078992"/>
+          </a:xfrm>
+          <a:prstGeom prst="rect">
+            <a:avLst/>
+          </a:prstGeom>
+          <a:solidFill>
+            <a:srgbClr val="FFF7E5"/>
+          </a:solidFill>
+          <a:ln>
+            <a:solidFill>
+              <a:srgbClr val="DAE2EC"/>
+            </a:solidFill>
+          </a:ln>
+        </p:spPr>
+        <p:style>
+          <a:lnRef idx="1">
+            <a:schemeClr val="accent1"/>
+          </a:lnRef>
+          <a:fillRef idx="3">
+            <a:schemeClr val="accent1"/>
+          </a:fillRef>
+          <a:effectRef idx="2">
+            <a:schemeClr val="accent1"/>
+          </a:effectRef>
+          <a:fontRef idx="minor">
+            <a:schemeClr val="lt1"/>
+          </a:fontRef>
+        </p:style>
+        <p:txBody>
+          <a:bodyPr rtlCol="0" anchor="ctr" lIns="146304" rIns="109728" tIns="109728"/>
+          <a:lstStyle/>
+          <a:p>
+            <a:pPr algn="ctr">
+              <a:defRPr sz="900">
+                <a:solidFill>
+                  <a:srgbClr val="64748B"/>
+                </a:solidFill>
+              </a:defRPr>
+            </a:pPr>
+            <a:r>
+              <a:t>Enterprise SSD / QLC</a:t>
+            </a:r>
+          </a:p>
+          <a:p>
+            <a:pPr>
+              <a:defRPr sz="2000" b="1">
+                <a:solidFill>
+                  <a:srgbClr val="122037"/>
+                </a:solidFill>
+              </a:defRPr>
+            </a:pPr>
+          </a:p>
+          <a:p>
+            <a:pPr>
+              <a:defRPr sz="850">
+                <a:solidFill>
+                  <a:srgbClr val="64748B"/>
+                </a:solidFill>
+              </a:defRPr>
+            </a:pPr>
+            <a:r>
+              <a:t>RAG, checkpointing, vector retrieval → TCO, endurance, retrieval latency</a:t>
+            </a:r>
+          </a:p>
+        </p:txBody>
+      </p:sp>
+      <p:sp>
+        <p:nvSpPr>
+          <p:cNvPr id="7" name="Rectangle 6"/>
+          <p:cNvSpPr/>
+          <p:nvPr/>
+        </p:nvSpPr>
+        <p:spPr>
+          <a:xfrm>
+            <a:off x="6263640" y="2926080"/>
+            <a:ext cx="5074920" cy="1078992"/>
+          </a:xfrm>
+          <a:prstGeom prst="rect">
+            <a:avLst/>
+          </a:prstGeom>
+          <a:solidFill>
+            <a:srgbClr val="F0F4F8"/>
+          </a:solidFill>
+          <a:ln>
+            <a:solidFill>
+              <a:srgbClr val="DAE2EC"/>
+            </a:solidFill>
+          </a:ln>
+        </p:spPr>
+        <p:style>
+          <a:lnRef idx="1">
+            <a:schemeClr val="accent1"/>
+          </a:lnRef>
+          <a:fillRef idx="3">
+            <a:schemeClr val="accent1"/>
+          </a:fillRef>
+          <a:effectRef idx="2">
+            <a:schemeClr val="accent1"/>
+          </a:effectRef>
+          <a:fontRef idx="minor">
+            <a:schemeClr val="lt1"/>
+          </a:fontRef>
+        </p:style>
+        <p:txBody>
+          <a:bodyPr rtlCol="0" anchor="ctr" lIns="146304" rIns="109728" tIns="109728"/>
+          <a:lstStyle/>
+          <a:p>
+            <a:pPr algn="ctr">
+              <a:defRPr sz="900">
+                <a:solidFill>
+                  <a:srgbClr val="64748B"/>
+                </a:solidFill>
+              </a:defRPr>
+            </a:pPr>
+            <a:r>
+              <a:t>CXL</a:t>
+            </a:r>
+          </a:p>
+          <a:p>
+            <a:pPr>
+              <a:defRPr sz="2000" b="1">
+                <a:solidFill>
+                  <a:srgbClr val="122037"/>
+                </a:solidFill>
+              </a:defRPr>
+            </a:pPr>
+          </a:p>
+          <a:p>
+            <a:pPr>
+              <a:defRPr sz="850">
+                <a:solidFill>
+                  <a:srgbClr val="64748B"/>
+                </a:solidFill>
+              </a:defRPr>
+            </a:pPr>
+            <a:r>
+              <a:t>고가동률 추론 cluster → memory expansion과 utilization recovery</a:t>
+            </a:r>
+          </a:p>
+        </p:txBody>
+      </p:sp>
+      <p:sp>
+        <p:nvSpPr>
+          <p:cNvPr id="8" name="TextBox 7"/>
           <p:cNvSpPr txBox="1"/>
           <p:nvPr/>
         </p:nvSpPr>
         <p:spPr>
           <a:xfrm>
-            <a:off x="822960" y="1234440"/>
-            <a:ext cx="1325880" cy="320040"/>
+            <a:off x="777240" y="4983480"/>
+            <a:ext cx="10698480" cy="502920"/>
           </a:xfrm>
           <a:prstGeom prst="rect">
             <a:avLst/>
@@ -5062,154 +6158,14 @@
           <a:lstStyle/>
           <a:p>
             <a:pPr algn="l">
-              <a:defRPr sz="1400" b="1">
-                <a:solidFill>
-                  <a:srgbClr val="0F9F6E"/>
-                </a:solidFill>
-              </a:defRPr>
-            </a:pPr>
-            <a:r>
-              <a:t>높음</a:t>
-            </a:r>
-          </a:p>
-        </p:txBody>
-      </p:sp>
-      <p:sp>
-        <p:nvSpPr>
-          <p:cNvPr id="5" name="TextBox 4"/>
-          <p:cNvSpPr txBox="1"/>
-          <p:nvPr/>
-        </p:nvSpPr>
-        <p:spPr>
-          <a:xfrm>
-            <a:off x="2240280" y="1234440"/>
-            <a:ext cx="3840480" cy="320040"/>
-          </a:xfrm>
-          <a:prstGeom prst="rect">
-            <a:avLst/>
-          </a:prstGeom>
-          <a:noFill/>
-        </p:spPr>
-        <p:txBody>
-          <a:bodyPr wrap="none" lIns="0" rIns="0" tIns="0" bIns="0">
-            <a:spAutoFit/>
-          </a:bodyPr>
-          <a:lstStyle/>
-          <a:p>
-            <a:pPr algn="l">
               <a:defRPr sz="1300" b="1">
                 <a:solidFill>
-                  <a:srgbClr val="1E293B"/>
-                </a:solidFill>
-              </a:defRPr>
-            </a:pPr>
-            <a:r>
-              <a:t>공식 model card / technical report</a:t>
-            </a:r>
-          </a:p>
-        </p:txBody>
-      </p:sp>
-      <p:sp>
-        <p:nvSpPr>
-          <p:cNvPr id="6" name="TextBox 5"/>
-          <p:cNvSpPr txBox="1"/>
-          <p:nvPr/>
-        </p:nvSpPr>
-        <p:spPr>
-          <a:xfrm>
-            <a:off x="6126480" y="1234440"/>
-            <a:ext cx="5120640" cy="320040"/>
-          </a:xfrm>
-          <a:prstGeom prst="rect">
-            <a:avLst/>
-          </a:prstGeom>
-          <a:noFill/>
-        </p:spPr>
-        <p:txBody>
-          <a:bodyPr wrap="none" lIns="0" rIns="0" tIns="0" bIns="0">
-            <a:spAutoFit/>
-          </a:bodyPr>
-          <a:lstStyle/>
-          <a:p>
-            <a:pPr algn="l">
-              <a:defRPr sz="1100" b="0">
-                <a:solidFill>
-                  <a:srgbClr val="64748B"/>
-                </a:solidFill>
-              </a:defRPr>
-            </a:pPr>
-            <a:r>
-              <a:t>DeepSeek 671B/37B, Qwen3 235B/22B, Phi-4 14B</a:t>
-            </a:r>
-          </a:p>
-        </p:txBody>
-      </p:sp>
-      <p:sp>
-        <p:nvSpPr>
-          <p:cNvPr id="7" name="TextBox 6"/>
-          <p:cNvSpPr txBox="1"/>
-          <p:nvPr/>
-        </p:nvSpPr>
-        <p:spPr>
-          <a:xfrm>
-            <a:off x="822960" y="2194560"/>
-            <a:ext cx="1325880" cy="320040"/>
-          </a:xfrm>
-          <a:prstGeom prst="rect">
-            <a:avLst/>
-          </a:prstGeom>
-          <a:noFill/>
-        </p:spPr>
-        <p:txBody>
-          <a:bodyPr wrap="none" lIns="0" rIns="0" tIns="0" bIns="0">
-            <a:spAutoFit/>
-          </a:bodyPr>
-          <a:lstStyle/>
-          <a:p>
-            <a:pPr algn="l">
-              <a:defRPr sz="1400" b="1">
-                <a:solidFill>
-                  <a:srgbClr val="2563EB"/>
-                </a:solidFill>
-              </a:defRPr>
-            </a:pPr>
-            <a:r>
-              <a:t>중간</a:t>
-            </a:r>
-          </a:p>
-        </p:txBody>
-      </p:sp>
-      <p:sp>
-        <p:nvSpPr>
-          <p:cNvPr id="8" name="TextBox 7"/>
-          <p:cNvSpPr txBox="1"/>
-          <p:nvPr/>
-        </p:nvSpPr>
-        <p:spPr>
-          <a:xfrm>
-            <a:off x="2240280" y="2194560"/>
-            <a:ext cx="3840480" cy="320040"/>
-          </a:xfrm>
-          <a:prstGeom prst="rect">
-            <a:avLst/>
-          </a:prstGeom>
-          <a:noFill/>
-        </p:spPr>
-        <p:txBody>
-          <a:bodyPr wrap="none" lIns="0" rIns="0" tIns="0" bIns="0">
-            <a:spAutoFit/>
-          </a:bodyPr>
-          <a:lstStyle/>
-          <a:p>
-            <a:pPr algn="l">
-              <a:defRPr sz="1300" b="1">
-                <a:solidFill>
-                  <a:srgbClr val="1E293B"/>
-                </a:solidFill>
-              </a:defRPr>
-            </a:pPr>
-            <a:r>
-              <a:t>공식 capacity 또는 hardware 발표</a:t>
+                  <a:srgbClr val="122037"/>
+                </a:solidFill>
+              </a:defRPr>
+            </a:pPr>
+            <a:r>
+              <a:t>권장 sales motion: model owner별 account brief, 제품별 proof pack, scenario envelope에 연결된 pricing/mix 논리.</a:t>
             </a:r>
           </a:p>
         </p:txBody>
@@ -5217,286 +6173,6 @@
       <p:sp>
         <p:nvSpPr>
           <p:cNvPr id="9" name="TextBox 8"/>
-          <p:cNvSpPr txBox="1"/>
-          <p:nvPr/>
-        </p:nvSpPr>
-        <p:spPr>
-          <a:xfrm>
-            <a:off x="6126480" y="2194560"/>
-            <a:ext cx="5120640" cy="320040"/>
-          </a:xfrm>
-          <a:prstGeom prst="rect">
-            <a:avLst/>
-          </a:prstGeom>
-          <a:noFill/>
-        </p:spPr>
-        <p:txBody>
-          <a:bodyPr wrap="none" lIns="0" rIns="0" tIns="0" bIns="0">
-            <a:spAutoFit/>
-          </a:bodyPr>
-          <a:lstStyle/>
-          <a:p>
-            <a:pPr algn="l">
-              <a:defRPr sz="1100" b="0">
-                <a:solidFill>
-                  <a:srgbClr val="64748B"/>
-                </a:solidFill>
-              </a:defRPr>
-            </a:pPr>
-            <a:r>
-              <a:t>OpenAI/Stargate GW, Google Ironwood, xAI Colossus</a:t>
-            </a:r>
-          </a:p>
-        </p:txBody>
-      </p:sp>
-      <p:sp>
-        <p:nvSpPr>
-          <p:cNvPr id="10" name="TextBox 9"/>
-          <p:cNvSpPr txBox="1"/>
-          <p:nvPr/>
-        </p:nvSpPr>
-        <p:spPr>
-          <a:xfrm>
-            <a:off x="822960" y="3154680"/>
-            <a:ext cx="1325880" cy="320040"/>
-          </a:xfrm>
-          <a:prstGeom prst="rect">
-            <a:avLst/>
-          </a:prstGeom>
-          <a:noFill/>
-        </p:spPr>
-        <p:txBody>
-          <a:bodyPr wrap="none" lIns="0" rIns="0" tIns="0" bIns="0">
-            <a:spAutoFit/>
-          </a:bodyPr>
-          <a:lstStyle/>
-          <a:p>
-            <a:pPr algn="l">
-              <a:defRPr sz="1400" b="1">
-                <a:solidFill>
-                  <a:srgbClr val="B4741E"/>
-                </a:solidFill>
-              </a:defRPr>
-            </a:pPr>
-            <a:r>
-              <a:t>낮음-중간</a:t>
-            </a:r>
-          </a:p>
-        </p:txBody>
-      </p:sp>
-      <p:sp>
-        <p:nvSpPr>
-          <p:cNvPr id="11" name="TextBox 10"/>
-          <p:cNvSpPr txBox="1"/>
-          <p:nvPr/>
-        </p:nvSpPr>
-        <p:spPr>
-          <a:xfrm>
-            <a:off x="2240280" y="3154680"/>
-            <a:ext cx="3840480" cy="320040"/>
-          </a:xfrm>
-          <a:prstGeom prst="rect">
-            <a:avLst/>
-          </a:prstGeom>
-          <a:noFill/>
-        </p:spPr>
-        <p:txBody>
-          <a:bodyPr wrap="none" lIns="0" rIns="0" tIns="0" bIns="0">
-            <a:spAutoFit/>
-          </a:bodyPr>
-          <a:lstStyle/>
-          <a:p>
-            <a:pPr algn="l">
-              <a:defRPr sz="1300" b="1">
-                <a:solidFill>
-                  <a:srgbClr val="1E293B"/>
-                </a:solidFill>
-              </a:defRPr>
-            </a:pPr>
-            <a:r>
-              <a:t>Active GW와 추론/학습 split</a:t>
-            </a:r>
-          </a:p>
-        </p:txBody>
-      </p:sp>
-      <p:sp>
-        <p:nvSpPr>
-          <p:cNvPr id="12" name="TextBox 11"/>
-          <p:cNvSpPr txBox="1"/>
-          <p:nvPr/>
-        </p:nvSpPr>
-        <p:spPr>
-          <a:xfrm>
-            <a:off x="6126480" y="3154680"/>
-            <a:ext cx="5120640" cy="320040"/>
-          </a:xfrm>
-          <a:prstGeom prst="rect">
-            <a:avLst/>
-          </a:prstGeom>
-          <a:noFill/>
-        </p:spPr>
-        <p:txBody>
-          <a:bodyPr wrap="none" lIns="0" rIns="0" tIns="0" bIns="0">
-            <a:spAutoFit/>
-          </a:bodyPr>
-          <a:lstStyle/>
-          <a:p>
-            <a:pPr algn="l">
-              <a:defRPr sz="1100" b="0">
-                <a:solidFill>
-                  <a:srgbClr val="64748B"/>
-                </a:solidFill>
-              </a:defRPr>
-            </a:pPr>
-            <a:r>
-              <a:t>telemetry 또는 site-level disclosure 필요</a:t>
-            </a:r>
-          </a:p>
-        </p:txBody>
-      </p:sp>
-      <p:sp>
-        <p:nvSpPr>
-          <p:cNvPr id="13" name="TextBox 12"/>
-          <p:cNvSpPr txBox="1"/>
-          <p:nvPr/>
-        </p:nvSpPr>
-        <p:spPr>
-          <a:xfrm>
-            <a:off x="822960" y="4114800"/>
-            <a:ext cx="1325880" cy="320040"/>
-          </a:xfrm>
-          <a:prstGeom prst="rect">
-            <a:avLst/>
-          </a:prstGeom>
-          <a:noFill/>
-        </p:spPr>
-        <p:txBody>
-          <a:bodyPr wrap="none" lIns="0" rIns="0" tIns="0" bIns="0">
-            <a:spAutoFit/>
-          </a:bodyPr>
-          <a:lstStyle/>
-          <a:p>
-            <a:pPr algn="l">
-              <a:defRPr sz="1400" b="1">
-                <a:solidFill>
-                  <a:srgbClr val="B93838"/>
-                </a:solidFill>
-              </a:defRPr>
-            </a:pPr>
-            <a:r>
-              <a:t>민감도</a:t>
-            </a:r>
-          </a:p>
-        </p:txBody>
-      </p:sp>
-      <p:sp>
-        <p:nvSpPr>
-          <p:cNvPr id="14" name="TextBox 13"/>
-          <p:cNvSpPr txBox="1"/>
-          <p:nvPr/>
-        </p:nvSpPr>
-        <p:spPr>
-          <a:xfrm>
-            <a:off x="2240280" y="4114800"/>
-            <a:ext cx="3840480" cy="320040"/>
-          </a:xfrm>
-          <a:prstGeom prst="rect">
-            <a:avLst/>
-          </a:prstGeom>
-          <a:noFill/>
-        </p:spPr>
-        <p:txBody>
-          <a:bodyPr wrap="none" lIns="0" rIns="0" tIns="0" bIns="0">
-            <a:spAutoFit/>
-          </a:bodyPr>
-          <a:lstStyle/>
-          <a:p>
-            <a:pPr algn="l">
-              <a:defRPr sz="1300" b="1">
-                <a:solidFill>
-                  <a:srgbClr val="1E293B"/>
-                </a:solidFill>
-              </a:defRPr>
-            </a:pPr>
-            <a:r>
-              <a:t>tokens/sec/MW와 utilization</a:t>
-            </a:r>
-          </a:p>
-        </p:txBody>
-      </p:sp>
-      <p:sp>
-        <p:nvSpPr>
-          <p:cNvPr id="15" name="TextBox 14"/>
-          <p:cNvSpPr txBox="1"/>
-          <p:nvPr/>
-        </p:nvSpPr>
-        <p:spPr>
-          <a:xfrm>
-            <a:off x="6126480" y="4114800"/>
-            <a:ext cx="5120640" cy="320040"/>
-          </a:xfrm>
-          <a:prstGeom prst="rect">
-            <a:avLst/>
-          </a:prstGeom>
-          <a:noFill/>
-        </p:spPr>
-        <p:txBody>
-          <a:bodyPr wrap="none" lIns="0" rIns="0" tIns="0" bIns="0">
-            <a:spAutoFit/>
-          </a:bodyPr>
-          <a:lstStyle/>
-          <a:p>
-            <a:pPr algn="l">
-              <a:defRPr sz="1100" b="0">
-                <a:solidFill>
-                  <a:srgbClr val="64748B"/>
-                </a:solidFill>
-              </a:defRPr>
-            </a:pPr>
-            <a:r>
-              <a:t>company fact가 아니라 scenario benchmark</a:t>
-            </a:r>
-          </a:p>
-        </p:txBody>
-      </p:sp>
-      <p:sp>
-        <p:nvSpPr>
-          <p:cNvPr id="16" name="TextBox 15"/>
-          <p:cNvSpPr txBox="1"/>
-          <p:nvPr/>
-        </p:nvSpPr>
-        <p:spPr>
-          <a:xfrm>
-            <a:off x="822960" y="5577840"/>
-            <a:ext cx="10515600" cy="411480"/>
-          </a:xfrm>
-          <a:prstGeom prst="rect">
-            <a:avLst/>
-          </a:prstGeom>
-          <a:noFill/>
-        </p:spPr>
-        <p:txBody>
-          <a:bodyPr wrap="none" lIns="0" rIns="0" tIns="0" bIns="0">
-            <a:spAutoFit/>
-          </a:bodyPr>
-          <a:lstStyle/>
-          <a:p>
-            <a:pPr algn="l">
-              <a:defRPr sz="1100" b="1">
-                <a:solidFill>
-                  <a:srgbClr val="122037"/>
-                </a:solidFill>
-              </a:defRPr>
-            </a:pPr>
-            <a:r>
-              <a:t>Replacement path: site-level MW activation, model routing mix, production API traffic, 모델/context별 실측 tokens/sec/MW.</a:t>
-            </a:r>
-          </a:p>
-        </p:txBody>
-      </p:sp>
-      <p:sp>
-        <p:nvSpPr>
-          <p:cNvPr id="17" name="TextBox 16"/>
           <p:cNvSpPr txBox="1"/>
           <p:nvPr/>
         </p:nvSpPr>
@@ -5585,6 +6261,1358 @@
               </a:defRPr>
             </a:pPr>
             <a:r>
+              <a:t>근거 신뢰도 감사</a:t>
+            </a:r>
+          </a:p>
+        </p:txBody>
+      </p:sp>
+      <p:sp>
+        <p:nvSpPr>
+          <p:cNvPr id="3" name="TextBox 2"/>
+          <p:cNvSpPr txBox="1"/>
+          <p:nvPr/>
+        </p:nvSpPr>
+        <p:spPr>
+          <a:xfrm>
+            <a:off x="530352" y="804672"/>
+            <a:ext cx="10881360" cy="310896"/>
+          </a:xfrm>
+          <a:prstGeom prst="rect">
+            <a:avLst/>
+          </a:prstGeom>
+          <a:noFill/>
+        </p:spPr>
+        <p:txBody>
+          <a:bodyPr wrap="none">
+            <a:spAutoFit/>
+          </a:bodyPr>
+          <a:lstStyle/>
+          <a:p>
+            <a:pPr>
+              <a:defRPr sz="1000">
+                <a:solidFill>
+                  <a:srgbClr val="64748B"/>
+                </a:solidFill>
+              </a:defRPr>
+            </a:pPr>
+            <a:r>
+              <a:t>가장 강한 근거는 모델 크기와 발표 capacity이며, 가장 약한 부분은 active serving utilization이다.</a:t>
+            </a:r>
+          </a:p>
+        </p:txBody>
+      </p:sp>
+      <p:sp>
+        <p:nvSpPr>
+          <p:cNvPr id="4" name="TextBox 3"/>
+          <p:cNvSpPr txBox="1"/>
+          <p:nvPr/>
+        </p:nvSpPr>
+        <p:spPr>
+          <a:xfrm>
+            <a:off x="822960" y="1234440"/>
+            <a:ext cx="1325880" cy="320040"/>
+          </a:xfrm>
+          <a:prstGeom prst="rect">
+            <a:avLst/>
+          </a:prstGeom>
+          <a:noFill/>
+        </p:spPr>
+        <p:txBody>
+          <a:bodyPr wrap="none" lIns="0" rIns="0" tIns="0" bIns="0">
+            <a:spAutoFit/>
+          </a:bodyPr>
+          <a:lstStyle/>
+          <a:p>
+            <a:pPr algn="l">
+              <a:defRPr sz="1400" b="1">
+                <a:solidFill>
+                  <a:srgbClr val="0F9F6E"/>
+                </a:solidFill>
+              </a:defRPr>
+            </a:pPr>
+            <a:r>
+              <a:t>높음</a:t>
+            </a:r>
+          </a:p>
+        </p:txBody>
+      </p:sp>
+      <p:sp>
+        <p:nvSpPr>
+          <p:cNvPr id="5" name="TextBox 4"/>
+          <p:cNvSpPr txBox="1"/>
+          <p:nvPr/>
+        </p:nvSpPr>
+        <p:spPr>
+          <a:xfrm>
+            <a:off x="2240280" y="1234440"/>
+            <a:ext cx="3840480" cy="320040"/>
+          </a:xfrm>
+          <a:prstGeom prst="rect">
+            <a:avLst/>
+          </a:prstGeom>
+          <a:noFill/>
+        </p:spPr>
+        <p:txBody>
+          <a:bodyPr wrap="none" lIns="0" rIns="0" tIns="0" bIns="0">
+            <a:spAutoFit/>
+          </a:bodyPr>
+          <a:lstStyle/>
+          <a:p>
+            <a:pPr algn="l">
+              <a:defRPr sz="1300" b="1">
+                <a:solidFill>
+                  <a:srgbClr val="1E293B"/>
+                </a:solidFill>
+              </a:defRPr>
+            </a:pPr>
+            <a:r>
+              <a:t>공식 model card / technical report</a:t>
+            </a:r>
+          </a:p>
+        </p:txBody>
+      </p:sp>
+      <p:sp>
+        <p:nvSpPr>
+          <p:cNvPr id="6" name="TextBox 5"/>
+          <p:cNvSpPr txBox="1"/>
+          <p:nvPr/>
+        </p:nvSpPr>
+        <p:spPr>
+          <a:xfrm>
+            <a:off x="6126480" y="1234440"/>
+            <a:ext cx="5120640" cy="320040"/>
+          </a:xfrm>
+          <a:prstGeom prst="rect">
+            <a:avLst/>
+          </a:prstGeom>
+          <a:noFill/>
+        </p:spPr>
+        <p:txBody>
+          <a:bodyPr wrap="none" lIns="0" rIns="0" tIns="0" bIns="0">
+            <a:spAutoFit/>
+          </a:bodyPr>
+          <a:lstStyle/>
+          <a:p>
+            <a:pPr algn="l">
+              <a:defRPr sz="1100" b="0">
+                <a:solidFill>
+                  <a:srgbClr val="64748B"/>
+                </a:solidFill>
+              </a:defRPr>
+            </a:pPr>
+            <a:r>
+              <a:t>DeepSeek 671B/37B, Qwen3 235B/22B, Phi-4 14B</a:t>
+            </a:r>
+          </a:p>
+        </p:txBody>
+      </p:sp>
+      <p:sp>
+        <p:nvSpPr>
+          <p:cNvPr id="7" name="TextBox 6"/>
+          <p:cNvSpPr txBox="1"/>
+          <p:nvPr/>
+        </p:nvSpPr>
+        <p:spPr>
+          <a:xfrm>
+            <a:off x="822960" y="2194560"/>
+            <a:ext cx="1325880" cy="320040"/>
+          </a:xfrm>
+          <a:prstGeom prst="rect">
+            <a:avLst/>
+          </a:prstGeom>
+          <a:noFill/>
+        </p:spPr>
+        <p:txBody>
+          <a:bodyPr wrap="none" lIns="0" rIns="0" tIns="0" bIns="0">
+            <a:spAutoFit/>
+          </a:bodyPr>
+          <a:lstStyle/>
+          <a:p>
+            <a:pPr algn="l">
+              <a:defRPr sz="1400" b="1">
+                <a:solidFill>
+                  <a:srgbClr val="2563EB"/>
+                </a:solidFill>
+              </a:defRPr>
+            </a:pPr>
+            <a:r>
+              <a:t>중간</a:t>
+            </a:r>
+          </a:p>
+        </p:txBody>
+      </p:sp>
+      <p:sp>
+        <p:nvSpPr>
+          <p:cNvPr id="8" name="TextBox 7"/>
+          <p:cNvSpPr txBox="1"/>
+          <p:nvPr/>
+        </p:nvSpPr>
+        <p:spPr>
+          <a:xfrm>
+            <a:off x="2240280" y="2194560"/>
+            <a:ext cx="3840480" cy="320040"/>
+          </a:xfrm>
+          <a:prstGeom prst="rect">
+            <a:avLst/>
+          </a:prstGeom>
+          <a:noFill/>
+        </p:spPr>
+        <p:txBody>
+          <a:bodyPr wrap="none" lIns="0" rIns="0" tIns="0" bIns="0">
+            <a:spAutoFit/>
+          </a:bodyPr>
+          <a:lstStyle/>
+          <a:p>
+            <a:pPr algn="l">
+              <a:defRPr sz="1300" b="1">
+                <a:solidFill>
+                  <a:srgbClr val="1E293B"/>
+                </a:solidFill>
+              </a:defRPr>
+            </a:pPr>
+            <a:r>
+              <a:t>공식 capacity 또는 hardware 발표</a:t>
+            </a:r>
+          </a:p>
+        </p:txBody>
+      </p:sp>
+      <p:sp>
+        <p:nvSpPr>
+          <p:cNvPr id="9" name="TextBox 8"/>
+          <p:cNvSpPr txBox="1"/>
+          <p:nvPr/>
+        </p:nvSpPr>
+        <p:spPr>
+          <a:xfrm>
+            <a:off x="6126480" y="2194560"/>
+            <a:ext cx="5120640" cy="320040"/>
+          </a:xfrm>
+          <a:prstGeom prst="rect">
+            <a:avLst/>
+          </a:prstGeom>
+          <a:noFill/>
+        </p:spPr>
+        <p:txBody>
+          <a:bodyPr wrap="none" lIns="0" rIns="0" tIns="0" bIns="0">
+            <a:spAutoFit/>
+          </a:bodyPr>
+          <a:lstStyle/>
+          <a:p>
+            <a:pPr algn="l">
+              <a:defRPr sz="1100" b="0">
+                <a:solidFill>
+                  <a:srgbClr val="64748B"/>
+                </a:solidFill>
+              </a:defRPr>
+            </a:pPr>
+            <a:r>
+              <a:t>OpenAI/Stargate GW, Google Ironwood, xAI Colossus</a:t>
+            </a:r>
+          </a:p>
+        </p:txBody>
+      </p:sp>
+      <p:sp>
+        <p:nvSpPr>
+          <p:cNvPr id="10" name="TextBox 9"/>
+          <p:cNvSpPr txBox="1"/>
+          <p:nvPr/>
+        </p:nvSpPr>
+        <p:spPr>
+          <a:xfrm>
+            <a:off x="822960" y="3154680"/>
+            <a:ext cx="1325880" cy="320040"/>
+          </a:xfrm>
+          <a:prstGeom prst="rect">
+            <a:avLst/>
+          </a:prstGeom>
+          <a:noFill/>
+        </p:spPr>
+        <p:txBody>
+          <a:bodyPr wrap="none" lIns="0" rIns="0" tIns="0" bIns="0">
+            <a:spAutoFit/>
+          </a:bodyPr>
+          <a:lstStyle/>
+          <a:p>
+            <a:pPr algn="l">
+              <a:defRPr sz="1400" b="1">
+                <a:solidFill>
+                  <a:srgbClr val="B4741E"/>
+                </a:solidFill>
+              </a:defRPr>
+            </a:pPr>
+            <a:r>
+              <a:t>낮음-중간</a:t>
+            </a:r>
+          </a:p>
+        </p:txBody>
+      </p:sp>
+      <p:sp>
+        <p:nvSpPr>
+          <p:cNvPr id="11" name="TextBox 10"/>
+          <p:cNvSpPr txBox="1"/>
+          <p:nvPr/>
+        </p:nvSpPr>
+        <p:spPr>
+          <a:xfrm>
+            <a:off x="2240280" y="3154680"/>
+            <a:ext cx="3840480" cy="320040"/>
+          </a:xfrm>
+          <a:prstGeom prst="rect">
+            <a:avLst/>
+          </a:prstGeom>
+          <a:noFill/>
+        </p:spPr>
+        <p:txBody>
+          <a:bodyPr wrap="none" lIns="0" rIns="0" tIns="0" bIns="0">
+            <a:spAutoFit/>
+          </a:bodyPr>
+          <a:lstStyle/>
+          <a:p>
+            <a:pPr algn="l">
+              <a:defRPr sz="1300" b="1">
+                <a:solidFill>
+                  <a:srgbClr val="1E293B"/>
+                </a:solidFill>
+              </a:defRPr>
+            </a:pPr>
+            <a:r>
+              <a:t>Active GW와 추론/학습 split</a:t>
+            </a:r>
+          </a:p>
+        </p:txBody>
+      </p:sp>
+      <p:sp>
+        <p:nvSpPr>
+          <p:cNvPr id="12" name="TextBox 11"/>
+          <p:cNvSpPr txBox="1"/>
+          <p:nvPr/>
+        </p:nvSpPr>
+        <p:spPr>
+          <a:xfrm>
+            <a:off x="6126480" y="3154680"/>
+            <a:ext cx="5120640" cy="320040"/>
+          </a:xfrm>
+          <a:prstGeom prst="rect">
+            <a:avLst/>
+          </a:prstGeom>
+          <a:noFill/>
+        </p:spPr>
+        <p:txBody>
+          <a:bodyPr wrap="none" lIns="0" rIns="0" tIns="0" bIns="0">
+            <a:spAutoFit/>
+          </a:bodyPr>
+          <a:lstStyle/>
+          <a:p>
+            <a:pPr algn="l">
+              <a:defRPr sz="1100" b="0">
+                <a:solidFill>
+                  <a:srgbClr val="64748B"/>
+                </a:solidFill>
+              </a:defRPr>
+            </a:pPr>
+            <a:r>
+              <a:t>telemetry 또는 site-level disclosure 필요</a:t>
+            </a:r>
+          </a:p>
+        </p:txBody>
+      </p:sp>
+      <p:sp>
+        <p:nvSpPr>
+          <p:cNvPr id="13" name="TextBox 12"/>
+          <p:cNvSpPr txBox="1"/>
+          <p:nvPr/>
+        </p:nvSpPr>
+        <p:spPr>
+          <a:xfrm>
+            <a:off x="822960" y="4114800"/>
+            <a:ext cx="1325880" cy="320040"/>
+          </a:xfrm>
+          <a:prstGeom prst="rect">
+            <a:avLst/>
+          </a:prstGeom>
+          <a:noFill/>
+        </p:spPr>
+        <p:txBody>
+          <a:bodyPr wrap="none" lIns="0" rIns="0" tIns="0" bIns="0">
+            <a:spAutoFit/>
+          </a:bodyPr>
+          <a:lstStyle/>
+          <a:p>
+            <a:pPr algn="l">
+              <a:defRPr sz="1400" b="1">
+                <a:solidFill>
+                  <a:srgbClr val="B93838"/>
+                </a:solidFill>
+              </a:defRPr>
+            </a:pPr>
+            <a:r>
+              <a:t>민감도</a:t>
+            </a:r>
+          </a:p>
+        </p:txBody>
+      </p:sp>
+      <p:sp>
+        <p:nvSpPr>
+          <p:cNvPr id="14" name="TextBox 13"/>
+          <p:cNvSpPr txBox="1"/>
+          <p:nvPr/>
+        </p:nvSpPr>
+        <p:spPr>
+          <a:xfrm>
+            <a:off x="2240280" y="4114800"/>
+            <a:ext cx="3840480" cy="320040"/>
+          </a:xfrm>
+          <a:prstGeom prst="rect">
+            <a:avLst/>
+          </a:prstGeom>
+          <a:noFill/>
+        </p:spPr>
+        <p:txBody>
+          <a:bodyPr wrap="none" lIns="0" rIns="0" tIns="0" bIns="0">
+            <a:spAutoFit/>
+          </a:bodyPr>
+          <a:lstStyle/>
+          <a:p>
+            <a:pPr algn="l">
+              <a:defRPr sz="1300" b="1">
+                <a:solidFill>
+                  <a:srgbClr val="1E293B"/>
+                </a:solidFill>
+              </a:defRPr>
+            </a:pPr>
+            <a:r>
+              <a:t>tokens/sec/MW와 utilization</a:t>
+            </a:r>
+          </a:p>
+        </p:txBody>
+      </p:sp>
+      <p:sp>
+        <p:nvSpPr>
+          <p:cNvPr id="15" name="TextBox 14"/>
+          <p:cNvSpPr txBox="1"/>
+          <p:nvPr/>
+        </p:nvSpPr>
+        <p:spPr>
+          <a:xfrm>
+            <a:off x="6126480" y="4114800"/>
+            <a:ext cx="5120640" cy="320040"/>
+          </a:xfrm>
+          <a:prstGeom prst="rect">
+            <a:avLst/>
+          </a:prstGeom>
+          <a:noFill/>
+        </p:spPr>
+        <p:txBody>
+          <a:bodyPr wrap="none" lIns="0" rIns="0" tIns="0" bIns="0">
+            <a:spAutoFit/>
+          </a:bodyPr>
+          <a:lstStyle/>
+          <a:p>
+            <a:pPr algn="l">
+              <a:defRPr sz="1100" b="0">
+                <a:solidFill>
+                  <a:srgbClr val="64748B"/>
+                </a:solidFill>
+              </a:defRPr>
+            </a:pPr>
+            <a:r>
+              <a:t>company fact가 아니라 scenario benchmark</a:t>
+            </a:r>
+          </a:p>
+        </p:txBody>
+      </p:sp>
+      <p:sp>
+        <p:nvSpPr>
+          <p:cNvPr id="16" name="TextBox 15"/>
+          <p:cNvSpPr txBox="1"/>
+          <p:nvPr/>
+        </p:nvSpPr>
+        <p:spPr>
+          <a:xfrm>
+            <a:off x="822960" y="5577840"/>
+            <a:ext cx="10515600" cy="411480"/>
+          </a:xfrm>
+          <a:prstGeom prst="rect">
+            <a:avLst/>
+          </a:prstGeom>
+          <a:noFill/>
+        </p:spPr>
+        <p:txBody>
+          <a:bodyPr wrap="none" lIns="0" rIns="0" tIns="0" bIns="0">
+            <a:spAutoFit/>
+          </a:bodyPr>
+          <a:lstStyle/>
+          <a:p>
+            <a:pPr algn="l">
+              <a:defRPr sz="1100" b="1">
+                <a:solidFill>
+                  <a:srgbClr val="122037"/>
+                </a:solidFill>
+              </a:defRPr>
+            </a:pPr>
+            <a:r>
+              <a:t>Replacement path: site-level MW activation, model routing mix, production API traffic, 모델/context별 실측 tokens/sec/MW.</a:t>
+            </a:r>
+          </a:p>
+        </p:txBody>
+      </p:sp>
+      <p:sp>
+        <p:nvSpPr>
+          <p:cNvPr id="17" name="TextBox 16"/>
+          <p:cNvSpPr txBox="1"/>
+          <p:nvPr/>
+        </p:nvSpPr>
+        <p:spPr>
+          <a:xfrm>
+            <a:off x="502920" y="6446520"/>
+            <a:ext cx="11201400" cy="219456"/>
+          </a:xfrm>
+          <a:prstGeom prst="rect">
+            <a:avLst/>
+          </a:prstGeom>
+          <a:noFill/>
+        </p:spPr>
+        <p:txBody>
+          <a:bodyPr wrap="none">
+            <a:spAutoFit/>
+          </a:bodyPr>
+          <a:lstStyle/>
+          <a:p>
+            <a:pPr>
+              <a:defRPr sz="750">
+                <a:solidFill>
+                  <a:srgbClr val="64748B"/>
+                </a:solidFill>
+              </a:defRPr>
+            </a:pPr>
+            <a:r>
+              <a:t>출처 기반 시뮬레이션 | Fact / Estimate / Scenario 분리 | 생성일 2026-05-14</a:t>
+            </a:r>
+          </a:p>
+        </p:txBody>
+      </p:sp>
+    </p:spTree>
+  </p:cSld>
+  <p:clrMapOvr>
+    <a:masterClrMapping/>
+  </p:clrMapOvr>
+</p:sld>
+</file>
+
+<file path=ppt/slides/slide13.xml><?xml version="1.0" encoding="utf-8"?>
+<p:sld xmlns:a="http://schemas.openxmlformats.org/drawingml/2006/main" xmlns:p="http://schemas.openxmlformats.org/presentationml/2006/main" xmlns:r="http://schemas.openxmlformats.org/officeDocument/2006/relationships">
+  <p:cSld>
+    <p:bg>
+      <p:bgPr>
+        <a:solidFill>
+          <a:srgbClr val="F7F9FC"/>
+        </a:solidFill>
+        <a:effectLst/>
+      </p:bgPr>
+    </p:bg>
+    <p:spTree>
+      <p:nvGrpSpPr>
+        <p:cNvPr id="1" name=""/>
+        <p:cNvGrpSpPr/>
+        <p:nvPr/>
+      </p:nvGrpSpPr>
+      <p:grpSpPr/>
+      <p:sp>
+        <p:nvSpPr>
+          <p:cNvPr id="2" name="TextBox 1"/>
+          <p:cNvSpPr txBox="1"/>
+          <p:nvPr/>
+        </p:nvSpPr>
+        <p:spPr>
+          <a:xfrm>
+            <a:off x="502920" y="310896"/>
+            <a:ext cx="11109960" cy="502920"/>
+          </a:xfrm>
+          <a:prstGeom prst="rect">
+            <a:avLst/>
+          </a:prstGeom>
+          <a:noFill/>
+        </p:spPr>
+        <p:txBody>
+          <a:bodyPr wrap="none">
+            <a:spAutoFit/>
+          </a:bodyPr>
+          <a:lstStyle/>
+          <a:p>
+            <a:pPr>
+              <a:defRPr sz="2300" b="1">
+                <a:solidFill>
+                  <a:srgbClr val="122037"/>
+                </a:solidFill>
+              </a:defRPr>
+            </a:pPr>
+            <a:r>
+              <a:t>Hallucination 체크리스트</a:t>
+            </a:r>
+          </a:p>
+        </p:txBody>
+      </p:sp>
+      <p:sp>
+        <p:nvSpPr>
+          <p:cNvPr id="3" name="TextBox 2"/>
+          <p:cNvSpPr txBox="1"/>
+          <p:nvPr/>
+        </p:nvSpPr>
+        <p:spPr>
+          <a:xfrm>
+            <a:off x="530352" y="804672"/>
+            <a:ext cx="10881360" cy="310896"/>
+          </a:xfrm>
+          <a:prstGeom prst="rect">
+            <a:avLst/>
+          </a:prstGeom>
+          <a:noFill/>
+        </p:spPr>
+        <p:txBody>
+          <a:bodyPr wrap="none">
+            <a:spAutoFit/>
+          </a:bodyPr>
+          <a:lstStyle/>
+          <a:p>
+            <a:pPr>
+              <a:defRPr sz="1000">
+                <a:solidFill>
+                  <a:srgbClr val="64748B"/>
+                </a:solidFill>
+              </a:defRPr>
+            </a:pPr>
+            <a:r>
+              <a:t>임원 보고 전 숫자와 문구가 fact/proxy/scenario를 혼동하지 않는지 확인합니다.</a:t>
+            </a:r>
+          </a:p>
+        </p:txBody>
+      </p:sp>
+      <p:sp>
+        <p:nvSpPr>
+          <p:cNvPr id="4" name="Rectangle 3"/>
+          <p:cNvSpPr/>
+          <p:nvPr/>
+        </p:nvSpPr>
+        <p:spPr>
+          <a:xfrm>
+            <a:off x="685800" y="1143000"/>
+            <a:ext cx="5166360" cy="749808"/>
+          </a:xfrm>
+          <a:prstGeom prst="rect">
+            <a:avLst/>
+          </a:prstGeom>
+          <a:solidFill>
+            <a:srgbClr val="EBF2FF"/>
+          </a:solidFill>
+          <a:ln>
+            <a:solidFill>
+              <a:srgbClr val="DAE2EC"/>
+            </a:solidFill>
+          </a:ln>
+        </p:spPr>
+        <p:style>
+          <a:lnRef idx="1">
+            <a:schemeClr val="accent1"/>
+          </a:lnRef>
+          <a:fillRef idx="3">
+            <a:schemeClr val="accent1"/>
+          </a:fillRef>
+          <a:effectRef idx="2">
+            <a:schemeClr val="accent1"/>
+          </a:effectRef>
+          <a:fontRef idx="minor">
+            <a:schemeClr val="lt1"/>
+          </a:fontRef>
+        </p:style>
+        <p:txBody>
+          <a:bodyPr rtlCol="0" anchor="ctr" lIns="146304" rIns="109728" tIns="109728"/>
+          <a:lstStyle/>
+          <a:p>
+            <a:pPr algn="ctr">
+              <a:defRPr sz="900">
+                <a:solidFill>
+                  <a:srgbClr val="64748B"/>
+                </a:solidFill>
+              </a:defRPr>
+            </a:pPr>
+            <a:r>
+              <a:t>출처 존재</a:t>
+            </a:r>
+          </a:p>
+          <a:p>
+            <a:pPr>
+              <a:defRPr sz="2000" b="1">
+                <a:solidFill>
+                  <a:srgbClr val="122037"/>
+                </a:solidFill>
+              </a:defRPr>
+            </a:pPr>
+          </a:p>
+          <a:p>
+            <a:pPr>
+              <a:defRPr sz="850">
+                <a:solidFill>
+                  <a:srgbClr val="64748B"/>
+                </a:solidFill>
+              </a:defRPr>
+            </a:pPr>
+            <a:r>
+              <a:t>URL/title/date 직접 확인</a:t>
+            </a:r>
+          </a:p>
+        </p:txBody>
+      </p:sp>
+      <p:sp>
+        <p:nvSpPr>
+          <p:cNvPr id="5" name="Rectangle 4"/>
+          <p:cNvSpPr/>
+          <p:nvPr/>
+        </p:nvSpPr>
+        <p:spPr>
+          <a:xfrm>
+            <a:off x="6309360" y="1143000"/>
+            <a:ext cx="5166360" cy="749808"/>
+          </a:xfrm>
+          <a:prstGeom prst="rect">
+            <a:avLst/>
+          </a:prstGeom>
+          <a:solidFill>
+            <a:srgbClr val="E8F8F0"/>
+          </a:solidFill>
+          <a:ln>
+            <a:solidFill>
+              <a:srgbClr val="DAE2EC"/>
+            </a:solidFill>
+          </a:ln>
+        </p:spPr>
+        <p:style>
+          <a:lnRef idx="1">
+            <a:schemeClr val="accent1"/>
+          </a:lnRef>
+          <a:fillRef idx="3">
+            <a:schemeClr val="accent1"/>
+          </a:fillRef>
+          <a:effectRef idx="2">
+            <a:schemeClr val="accent1"/>
+          </a:effectRef>
+          <a:fontRef idx="minor">
+            <a:schemeClr val="lt1"/>
+          </a:fontRef>
+        </p:style>
+        <p:txBody>
+          <a:bodyPr rtlCol="0" anchor="ctr" lIns="146304" rIns="109728" tIns="109728"/>
+          <a:lstStyle/>
+          <a:p>
+            <a:pPr algn="ctr">
+              <a:defRPr sz="900">
+                <a:solidFill>
+                  <a:srgbClr val="64748B"/>
+                </a:solidFill>
+              </a:defRPr>
+            </a:pPr>
+            <a:r>
+              <a:t>숫자 직접 인용</a:t>
+            </a:r>
+          </a:p>
+          <a:p>
+            <a:pPr>
+              <a:defRPr sz="2000" b="1">
+                <a:solidFill>
+                  <a:srgbClr val="122037"/>
+                </a:solidFill>
+              </a:defRPr>
+            </a:pPr>
+          </a:p>
+          <a:p>
+            <a:pPr>
+              <a:defRPr sz="850">
+                <a:solidFill>
+                  <a:srgbClr val="64748B"/>
+                </a:solidFill>
+              </a:defRPr>
+            </a:pPr>
+            <a:r>
+              <a:t>4.5GW, 671B/37B 등 원문 매칭</a:t>
+            </a:r>
+          </a:p>
+        </p:txBody>
+      </p:sp>
+      <p:sp>
+        <p:nvSpPr>
+          <p:cNvPr id="6" name="Rectangle 5"/>
+          <p:cNvSpPr/>
+          <p:nvPr/>
+        </p:nvSpPr>
+        <p:spPr>
+          <a:xfrm>
+            <a:off x="685800" y="2194560"/>
+            <a:ext cx="5166360" cy="749808"/>
+          </a:xfrm>
+          <a:prstGeom prst="rect">
+            <a:avLst/>
+          </a:prstGeom>
+          <a:solidFill>
+            <a:srgbClr val="FFF7E5"/>
+          </a:solidFill>
+          <a:ln>
+            <a:solidFill>
+              <a:srgbClr val="DAE2EC"/>
+            </a:solidFill>
+          </a:ln>
+        </p:spPr>
+        <p:style>
+          <a:lnRef idx="1">
+            <a:schemeClr val="accent1"/>
+          </a:lnRef>
+          <a:fillRef idx="3">
+            <a:schemeClr val="accent1"/>
+          </a:fillRef>
+          <a:effectRef idx="2">
+            <a:schemeClr val="accent1"/>
+          </a:effectRef>
+          <a:fontRef idx="minor">
+            <a:schemeClr val="lt1"/>
+          </a:fontRef>
+        </p:style>
+        <p:txBody>
+          <a:bodyPr rtlCol="0" anchor="ctr" lIns="146304" rIns="109728" tIns="109728"/>
+          <a:lstStyle/>
+          <a:p>
+            <a:pPr algn="ctr">
+              <a:defRPr sz="900">
+                <a:solidFill>
+                  <a:srgbClr val="64748B"/>
+                </a:solidFill>
+              </a:defRPr>
+            </a:pPr>
+            <a:r>
+              <a:t>Fact/Estimate 분리</a:t>
+            </a:r>
+          </a:p>
+          <a:p>
+            <a:pPr>
+              <a:defRPr sz="2000" b="1">
+                <a:solidFill>
+                  <a:srgbClr val="122037"/>
+                </a:solidFill>
+              </a:defRPr>
+            </a:pPr>
+          </a:p>
+          <a:p>
+            <a:pPr>
+              <a:defRPr sz="850">
+                <a:solidFill>
+                  <a:srgbClr val="64748B"/>
+                </a:solidFill>
+              </a:defRPr>
+            </a:pPr>
+            <a:r>
+              <a:t>active GW·utilization은 scenario</a:t>
+            </a:r>
+          </a:p>
+        </p:txBody>
+      </p:sp>
+      <p:sp>
+        <p:nvSpPr>
+          <p:cNvPr id="7" name="Rectangle 6"/>
+          <p:cNvSpPr/>
+          <p:nvPr/>
+        </p:nvSpPr>
+        <p:spPr>
+          <a:xfrm>
+            <a:off x="6309360" y="2194560"/>
+            <a:ext cx="5166360" cy="749808"/>
+          </a:xfrm>
+          <a:prstGeom prst="rect">
+            <a:avLst/>
+          </a:prstGeom>
+          <a:solidFill>
+            <a:srgbClr val="F0F4F8"/>
+          </a:solidFill>
+          <a:ln>
+            <a:solidFill>
+              <a:srgbClr val="DAE2EC"/>
+            </a:solidFill>
+          </a:ln>
+        </p:spPr>
+        <p:style>
+          <a:lnRef idx="1">
+            <a:schemeClr val="accent1"/>
+          </a:lnRef>
+          <a:fillRef idx="3">
+            <a:schemeClr val="accent1"/>
+          </a:fillRef>
+          <a:effectRef idx="2">
+            <a:schemeClr val="accent1"/>
+          </a:effectRef>
+          <a:fontRef idx="minor">
+            <a:schemeClr val="lt1"/>
+          </a:fontRef>
+        </p:style>
+        <p:txBody>
+          <a:bodyPr rtlCol="0" anchor="ctr" lIns="146304" rIns="109728" tIns="109728"/>
+          <a:lstStyle/>
+          <a:p>
+            <a:pPr algn="ctr">
+              <a:defRPr sz="900">
+                <a:solidFill>
+                  <a:srgbClr val="64748B"/>
+                </a:solidFill>
+              </a:defRPr>
+            </a:pPr>
+            <a:r>
+              <a:t>Closed model</a:t>
+            </a:r>
+          </a:p>
+          <a:p>
+            <a:pPr>
+              <a:defRPr sz="2000" b="1">
+                <a:solidFill>
+                  <a:srgbClr val="122037"/>
+                </a:solidFill>
+              </a:defRPr>
+            </a:pPr>
+          </a:p>
+          <a:p>
+            <a:pPr>
+              <a:defRPr sz="850">
+                <a:solidFill>
+                  <a:srgbClr val="64748B"/>
+                </a:solidFill>
+              </a:defRPr>
+            </a:pPr>
+            <a:r>
+              <a:t>precise parameter 금지</a:t>
+            </a:r>
+          </a:p>
+        </p:txBody>
+      </p:sp>
+      <p:sp>
+        <p:nvSpPr>
+          <p:cNvPr id="8" name="Rectangle 7"/>
+          <p:cNvSpPr/>
+          <p:nvPr/>
+        </p:nvSpPr>
+        <p:spPr>
+          <a:xfrm>
+            <a:off x="685800" y="3246120"/>
+            <a:ext cx="5166360" cy="749808"/>
+          </a:xfrm>
+          <a:prstGeom prst="rect">
+            <a:avLst/>
+          </a:prstGeom>
+          <a:solidFill>
+            <a:srgbClr val="EBF2FF"/>
+          </a:solidFill>
+          <a:ln>
+            <a:solidFill>
+              <a:srgbClr val="DAE2EC"/>
+            </a:solidFill>
+          </a:ln>
+        </p:spPr>
+        <p:style>
+          <a:lnRef idx="1">
+            <a:schemeClr val="accent1"/>
+          </a:lnRef>
+          <a:fillRef idx="3">
+            <a:schemeClr val="accent1"/>
+          </a:fillRef>
+          <a:effectRef idx="2">
+            <a:schemeClr val="accent1"/>
+          </a:effectRef>
+          <a:fontRef idx="minor">
+            <a:schemeClr val="lt1"/>
+          </a:fontRef>
+        </p:style>
+        <p:txBody>
+          <a:bodyPr rtlCol="0" anchor="ctr" lIns="146304" rIns="109728" tIns="109728"/>
+          <a:lstStyle/>
+          <a:p>
+            <a:pPr algn="ctr">
+              <a:defRPr sz="900">
+                <a:solidFill>
+                  <a:srgbClr val="64748B"/>
+                </a:solidFill>
+              </a:defRPr>
+            </a:pPr>
+            <a:r>
+              <a:t>Host attribution</a:t>
+            </a:r>
+          </a:p>
+          <a:p>
+            <a:pPr>
+              <a:defRPr sz="2000" b="1">
+                <a:solidFill>
+                  <a:srgbClr val="122037"/>
+                </a:solidFill>
+              </a:defRPr>
+            </a:pPr>
+          </a:p>
+          <a:p>
+            <a:pPr>
+              <a:defRPr sz="850">
+                <a:solidFill>
+                  <a:srgbClr val="64748B"/>
+                </a:solidFill>
+              </a:defRPr>
+            </a:pPr>
+            <a:r>
+              <a:t>AWS/Oracle/Google host와 model owner 분리</a:t>
+            </a:r>
+          </a:p>
+        </p:txBody>
+      </p:sp>
+      <p:sp>
+        <p:nvSpPr>
+          <p:cNvPr id="9" name="Rectangle 8"/>
+          <p:cNvSpPr/>
+          <p:nvPr/>
+        </p:nvSpPr>
+        <p:spPr>
+          <a:xfrm>
+            <a:off x="6309360" y="3246120"/>
+            <a:ext cx="5166360" cy="749808"/>
+          </a:xfrm>
+          <a:prstGeom prst="rect">
+            <a:avLst/>
+          </a:prstGeom>
+          <a:solidFill>
+            <a:srgbClr val="E8F8F0"/>
+          </a:solidFill>
+          <a:ln>
+            <a:solidFill>
+              <a:srgbClr val="DAE2EC"/>
+            </a:solidFill>
+          </a:ln>
+        </p:spPr>
+        <p:style>
+          <a:lnRef idx="1">
+            <a:schemeClr val="accent1"/>
+          </a:lnRef>
+          <a:fillRef idx="3">
+            <a:schemeClr val="accent1"/>
+          </a:fillRef>
+          <a:effectRef idx="2">
+            <a:schemeClr val="accent1"/>
+          </a:effectRef>
+          <a:fontRef idx="minor">
+            <a:schemeClr val="lt1"/>
+          </a:fontRef>
+        </p:style>
+        <p:txBody>
+          <a:bodyPr rtlCol="0" anchor="ctr" lIns="146304" rIns="109728" tIns="109728"/>
+          <a:lstStyle/>
+          <a:p>
+            <a:pPr algn="ctr">
+              <a:defRPr sz="900">
+                <a:solidFill>
+                  <a:srgbClr val="64748B"/>
+                </a:solidFill>
+              </a:defRPr>
+            </a:pPr>
+            <a:r>
+              <a:t>Benchmark proxy</a:t>
+            </a:r>
+          </a:p>
+          <a:p>
+            <a:pPr>
+              <a:defRPr sz="2000" b="1">
+                <a:solidFill>
+                  <a:srgbClr val="122037"/>
+                </a:solidFill>
+              </a:defRPr>
+            </a:pPr>
+          </a:p>
+          <a:p>
+            <a:pPr>
+              <a:defRPr sz="850">
+                <a:solidFill>
+                  <a:srgbClr val="64748B"/>
+                </a:solidFill>
+              </a:defRPr>
+            </a:pPr>
+            <a:r>
+              <a:t>closed model 결론이 아니라 sanity check</a:t>
+            </a:r>
+          </a:p>
+        </p:txBody>
+      </p:sp>
+      <p:sp>
+        <p:nvSpPr>
+          <p:cNvPr id="10" name="Rectangle 9"/>
+          <p:cNvSpPr/>
+          <p:nvPr/>
+        </p:nvSpPr>
+        <p:spPr>
+          <a:xfrm>
+            <a:off x="685800" y="4297679"/>
+            <a:ext cx="5166360" cy="749808"/>
+          </a:xfrm>
+          <a:prstGeom prst="rect">
+            <a:avLst/>
+          </a:prstGeom>
+          <a:solidFill>
+            <a:srgbClr val="FFF7E5"/>
+          </a:solidFill>
+          <a:ln>
+            <a:solidFill>
+              <a:srgbClr val="DAE2EC"/>
+            </a:solidFill>
+          </a:ln>
+        </p:spPr>
+        <p:style>
+          <a:lnRef idx="1">
+            <a:schemeClr val="accent1"/>
+          </a:lnRef>
+          <a:fillRef idx="3">
+            <a:schemeClr val="accent1"/>
+          </a:fillRef>
+          <a:effectRef idx="2">
+            <a:schemeClr val="accent1"/>
+          </a:effectRef>
+          <a:fontRef idx="minor">
+            <a:schemeClr val="lt1"/>
+          </a:fontRef>
+        </p:style>
+        <p:txBody>
+          <a:bodyPr rtlCol="0" anchor="ctr" lIns="146304" rIns="109728" tIns="109728"/>
+          <a:lstStyle/>
+          <a:p>
+            <a:pPr algn="ctr">
+              <a:defRPr sz="900">
+                <a:solidFill>
+                  <a:srgbClr val="64748B"/>
+                </a:solidFill>
+              </a:defRPr>
+            </a:pPr>
+            <a:r>
+              <a:t>단위</a:t>
+            </a:r>
+          </a:p>
+          <a:p>
+            <a:pPr>
+              <a:defRPr sz="2000" b="1">
+                <a:solidFill>
+                  <a:srgbClr val="122037"/>
+                </a:solidFill>
+              </a:defRPr>
+            </a:pPr>
+          </a:p>
+          <a:p>
+            <a:pPr>
+              <a:defRPr sz="850">
+                <a:solidFill>
+                  <a:srgbClr val="64748B"/>
+                </a:solidFill>
+              </a:defRPr>
+            </a:pPr>
+            <a:r>
+              <a:t>daily vs annual token 혼동 금지</a:t>
+            </a:r>
+          </a:p>
+        </p:txBody>
+      </p:sp>
+      <p:sp>
+        <p:nvSpPr>
+          <p:cNvPr id="11" name="Rectangle 10"/>
+          <p:cNvSpPr/>
+          <p:nvPr/>
+        </p:nvSpPr>
+        <p:spPr>
+          <a:xfrm>
+            <a:off x="6309360" y="4297679"/>
+            <a:ext cx="5166360" cy="749808"/>
+          </a:xfrm>
+          <a:prstGeom prst="rect">
+            <a:avLst/>
+          </a:prstGeom>
+          <a:solidFill>
+            <a:srgbClr val="F0F4F8"/>
+          </a:solidFill>
+          <a:ln>
+            <a:solidFill>
+              <a:srgbClr val="DAE2EC"/>
+            </a:solidFill>
+          </a:ln>
+        </p:spPr>
+        <p:style>
+          <a:lnRef idx="1">
+            <a:schemeClr val="accent1"/>
+          </a:lnRef>
+          <a:fillRef idx="3">
+            <a:schemeClr val="accent1"/>
+          </a:fillRef>
+          <a:effectRef idx="2">
+            <a:schemeClr val="accent1"/>
+          </a:effectRef>
+          <a:fontRef idx="minor">
+            <a:schemeClr val="lt1"/>
+          </a:fontRef>
+        </p:style>
+        <p:txBody>
+          <a:bodyPr rtlCol="0" anchor="ctr" lIns="146304" rIns="109728" tIns="109728"/>
+          <a:lstStyle/>
+          <a:p>
+            <a:pPr algn="ctr">
+              <a:defRPr sz="900">
+                <a:solidFill>
+                  <a:srgbClr val="64748B"/>
+                </a:solidFill>
+              </a:defRPr>
+            </a:pPr>
+            <a:r>
+              <a:t>Outlier</a:t>
+            </a:r>
+          </a:p>
+          <a:p>
+            <a:pPr>
+              <a:defRPr sz="2000" b="1">
+                <a:solidFill>
+                  <a:srgbClr val="122037"/>
+                </a:solidFill>
+              </a:defRPr>
+            </a:pPr>
+          </a:p>
+          <a:p>
+            <a:pPr>
+              <a:defRPr sz="850">
+                <a:solidFill>
+                  <a:srgbClr val="64748B"/>
+                </a:solidFill>
+              </a:defRPr>
+            </a:pPr>
+            <a:r>
+              <a:t>benchmark_vs_model ±50% 초과 review</a:t>
+            </a:r>
+          </a:p>
+        </p:txBody>
+      </p:sp>
+      <p:sp>
+        <p:nvSpPr>
+          <p:cNvPr id="12" name="TextBox 11"/>
+          <p:cNvSpPr txBox="1"/>
+          <p:nvPr/>
+        </p:nvSpPr>
+        <p:spPr>
+          <a:xfrm>
+            <a:off x="777240" y="5715000"/>
+            <a:ext cx="10607040" cy="320040"/>
+          </a:xfrm>
+          <a:prstGeom prst="rect">
+            <a:avLst/>
+          </a:prstGeom>
+          <a:noFill/>
+        </p:spPr>
+        <p:txBody>
+          <a:bodyPr wrap="none" lIns="0" rIns="0" tIns="0" bIns="0">
+            <a:spAutoFit/>
+          </a:bodyPr>
+          <a:lstStyle/>
+          <a:p>
+            <a:pPr algn="l">
+              <a:defRPr sz="1000" b="1">
+                <a:solidFill>
+                  <a:srgbClr val="122037"/>
+                </a:solidFill>
+              </a:defRPr>
+            </a:pPr>
+            <a:r>
+              <a:t>전체 체크리스트는 Excel `11_hallucination_checklist`에 수록되어 있으며, source screenshot/quote pack으로 최종 sign-off해야 합니다.</a:t>
+            </a:r>
+          </a:p>
+        </p:txBody>
+      </p:sp>
+      <p:sp>
+        <p:nvSpPr>
+          <p:cNvPr id="13" name="TextBox 12"/>
+          <p:cNvSpPr txBox="1"/>
+          <p:nvPr/>
+        </p:nvSpPr>
+        <p:spPr>
+          <a:xfrm>
+            <a:off x="502920" y="6446520"/>
+            <a:ext cx="11201400" cy="219456"/>
+          </a:xfrm>
+          <a:prstGeom prst="rect">
+            <a:avLst/>
+          </a:prstGeom>
+          <a:noFill/>
+        </p:spPr>
+        <p:txBody>
+          <a:bodyPr wrap="none">
+            <a:spAutoFit/>
+          </a:bodyPr>
+          <a:lstStyle/>
+          <a:p>
+            <a:pPr>
+              <a:defRPr sz="750">
+                <a:solidFill>
+                  <a:srgbClr val="64748B"/>
+                </a:solidFill>
+              </a:defRPr>
+            </a:pPr>
+            <a:r>
+              <a:t>출처 기반 시뮬레이션 | Fact / Estimate / Scenario 분리 | 생성일 2026-05-14</a:t>
+            </a:r>
+          </a:p>
+        </p:txBody>
+      </p:sp>
+    </p:spTree>
+  </p:cSld>
+  <p:clrMapOvr>
+    <a:masterClrMapping/>
+  </p:clrMapOvr>
+</p:sld>
+</file>
+
+<file path=ppt/slides/slide14.xml><?xml version="1.0" encoding="utf-8"?>
+<p:sld xmlns:a="http://schemas.openxmlformats.org/drawingml/2006/main" xmlns:p="http://schemas.openxmlformats.org/presentationml/2006/main" xmlns:r="http://schemas.openxmlformats.org/officeDocument/2006/relationships">
+  <p:cSld>
+    <p:bg>
+      <p:bgPr>
+        <a:solidFill>
+          <a:srgbClr val="F7F9FC"/>
+        </a:solidFill>
+        <a:effectLst/>
+      </p:bgPr>
+    </p:bg>
+    <p:spTree>
+      <p:nvGrpSpPr>
+        <p:cNvPr id="1" name=""/>
+        <p:cNvGrpSpPr/>
+        <p:nvPr/>
+      </p:nvGrpSpPr>
+      <p:grpSpPr/>
+      <p:sp>
+        <p:nvSpPr>
+          <p:cNvPr id="2" name="TextBox 1"/>
+          <p:cNvSpPr txBox="1"/>
+          <p:nvPr/>
+        </p:nvSpPr>
+        <p:spPr>
+          <a:xfrm>
+            <a:off x="502920" y="310896"/>
+            <a:ext cx="11109960" cy="502920"/>
+          </a:xfrm>
+          <a:prstGeom prst="rect">
+            <a:avLst/>
+          </a:prstGeom>
+          <a:noFill/>
+        </p:spPr>
+        <p:txBody>
+          <a:bodyPr wrap="none">
+            <a:spAutoFit/>
+          </a:bodyPr>
+          <a:lstStyle/>
+          <a:p>
+            <a:pPr>
+              <a:defRPr sz="2300" b="1">
+                <a:solidFill>
+                  <a:srgbClr val="122037"/>
+                </a:solidFill>
+              </a:defRPr>
+            </a:pPr>
+            <a:r>
               <a:t>부록: 계산 검증 컨트롤</a:t>
             </a:r>
           </a:p>
@@ -5688,7 +7716,22 @@
               </a:defRPr>
             </a:pPr>
             <a:r>
-              <a:t>08a/08b/08c: 시나리오 정의, 업체-연도별 forecast, aggregate scenario summary.</a:t>
+              <a:t>08a/08b/08c/08d: 시나리오 정의, 업체-연도별 forecast, aggregate summary, benchmark reference.</a:t>
+            </a:r>
+          </a:p>
+          <a:p>
+            <a:pPr>
+              <a:spcAft>
+                <a:spcPts val="800"/>
+              </a:spcAft>
+              <a:defRPr sz="1500">
+                <a:solidFill>
+                  <a:srgbClr val="1E293B"/>
+                </a:solidFill>
+              </a:defRPr>
+            </a:pPr>
+            <a:r>
+              <a:t>11_hallucination_checklist: fact/proxy/scenario 혼동 방지용 검토표.</a:t>
             </a:r>
           </a:p>
           <a:p>
@@ -6894,7 +8937,7 @@
               </a:defRPr>
             </a:pPr>
             <a:r>
-              <a:t>1.33Q/일</a:t>
+              <a:t>1.49Q/일</a:t>
             </a:r>
           </a:p>
           <a:p>
@@ -6972,7 +9015,7 @@
               </a:defRPr>
             </a:pPr>
             <a:r>
-              <a:t>2.55Q/일</a:t>
+              <a:t>2.87Q/일</a:t>
             </a:r>
           </a:p>
           <a:p>
@@ -7050,7 +9093,7 @@
               </a:defRPr>
             </a:pPr>
             <a:r>
-              <a:t>4.27Q/일</a:t>
+              <a:t>4.79Q/일</a:t>
             </a:r>
           </a:p>
           <a:p>
@@ -7128,7 +9171,7 @@
               </a:defRPr>
             </a:pPr>
             <a:r>
-              <a:t>2.40Q/일</a:t>
+              <a:t>2.69Q/일</a:t>
             </a:r>
           </a:p>
           <a:p>
@@ -7511,7 +9554,7 @@
               </a:defRPr>
             </a:pPr>
             <a:r>
-              <a:t>6.3 GW</a:t>
+              <a:t>7.3 GW</a:t>
             </a:r>
           </a:p>
           <a:p>
@@ -8558,7 +10601,7 @@
               </a:defRPr>
             </a:pPr>
             <a:r>
-              <a:t>추론 비중 fact-check</a:t>
+              <a:t>Benchmark sanity check</a:t>
             </a:r>
           </a:p>
         </p:txBody>
@@ -8593,7 +10636,7 @@
               </a:defRPr>
             </a:pPr>
             <a:r>
-              <a:t>이 모델은 2026년 60%+ 추론 GW를 fact로 취급하지 않는다.</a:t>
+              <a:t>첨부 엑셀의 effective active params와 GPU count 방식을 별도 reference layer로 통합했다.</a:t>
             </a:r>
           </a:p>
         </p:txBody>
@@ -8607,8 +10650,8 @@
           <p:nvPr/>
         </p:nvGraphicFramePr>
         <p:xfrm>
-          <a:off x="731520" y="1234440"/>
-          <a:ext cx="6583680" cy="4160520"/>
+          <a:off x="594360" y="1143000"/>
+          <a:ext cx="7452360" cy="4434840"/>
         </p:xfrm>
         <a:graphic>
           <a:graphicData uri="http://schemas.openxmlformats.org/drawingml/2006/chart">
@@ -8624,8 +10667,8 @@
         </p:nvSpPr>
         <p:spPr>
           <a:xfrm>
-            <a:off x="7726679" y="1325880"/>
-            <a:ext cx="3611880" cy="3657600"/>
+            <a:off x="8275320" y="1325880"/>
+            <a:ext cx="3063240" cy="3840480"/>
           </a:xfrm>
           <a:prstGeom prst="rect">
             <a:avLst/>
@@ -8642,14 +10685,14 @@
               <a:spcAft>
                 <a:spcPts val="800"/>
               </a:spcAft>
-              <a:defRPr sz="1300">
+              <a:defRPr sz="1100">
                 <a:solidFill>
                   <a:srgbClr val="1E293B"/>
                 </a:solidFill>
               </a:defRPr>
             </a:pPr>
             <a:r>
-              <a:t>기준 2026: 56%, 60% 미만.</a:t>
+              <a:t>Main forecast는 tokens/sec/MW 방식.</a:t>
             </a:r>
           </a:p>
           <a:p>
@@ -8657,14 +10700,14 @@
               <a:spcAft>
                 <a:spcPts val="800"/>
               </a:spcAft>
-              <a:defRPr sz="1300">
+              <a:defRPr sz="1100">
                 <a:solidFill>
                   <a:srgbClr val="1E293B"/>
                 </a:solidFill>
               </a:defRPr>
             </a:pPr>
             <a:r>
-              <a:t>낙관 2026: 61%, upside scenario에서만 허용.</a:t>
+              <a:t>Benchmark layer는 GPU 수와 effective active params로 sanity check.</a:t>
             </a:r>
           </a:p>
           <a:p>
@@ -8672,14 +10715,14 @@
               <a:spcAft>
                 <a:spcPts val="800"/>
               </a:spcAft>
-              <a:defRPr sz="1300">
+              <a:defRPr sz="1100">
                 <a:solidFill>
                   <a:srgbClr val="1E293B"/>
                 </a:solidFill>
               </a:defRPr>
             </a:pPr>
             <a:r>
-              <a:t>기준 2030: 76%, 상용 serving 확대 반영.</a:t>
+              <a:t>Closed model benchmark는 proxy이므로 결론이 아니라 guardrail.</a:t>
             </a:r>
           </a:p>
           <a:p>
@@ -8687,14 +10730,14 @@
               <a:spcAft>
                 <a:spcPts val="800"/>
               </a:spcAft>
-              <a:defRPr sz="1300">
+              <a:defRPr sz="1100">
                 <a:solidFill>
                   <a:srgbClr val="1E293B"/>
                 </a:solidFill>
               </a:defRPr>
             </a:pPr>
             <a:r>
-              <a:t>모든 case에서 학습 capacity는 계속 유의미하게 남김.</a:t>
+              <a:t>큰 괴리는 confidence downgrade 신호.</a:t>
             </a:r>
           </a:p>
         </p:txBody>
@@ -8790,7 +10833,7 @@
               </a:defRPr>
             </a:pPr>
             <a:r>
-              <a:t>모델 보유 업체 landscape</a:t>
+              <a:t>추론 비중 fact-check</a:t>
             </a:r>
           </a:p>
         </p:txBody>
@@ -8825,56 +10868,29 @@
               </a:defRPr>
             </a:pPr>
             <a:r>
-              <a:t>Core row는 데이터센터 host가 아니라 상용 LLM owner다.</a:t>
-            </a:r>
-          </a:p>
-        </p:txBody>
-      </p:sp>
-      <p:sp>
-        <p:nvSpPr>
-          <p:cNvPr id="4" name="Rectangle 3"/>
-          <p:cNvSpPr/>
-          <p:nvPr/>
-        </p:nvSpPr>
-        <p:spPr>
-          <a:xfrm>
-            <a:off x="731520" y="1234440"/>
-            <a:ext cx="3337560" cy="4297680"/>
-          </a:xfrm>
-          <a:prstGeom prst="rect">
-            <a:avLst/>
-          </a:prstGeom>
-          <a:solidFill>
-            <a:srgbClr val="EBF2FF"/>
-          </a:solidFill>
-          <a:ln>
-            <a:solidFill>
-              <a:srgbClr val="DAE2EC"/>
-            </a:solidFill>
-          </a:ln>
-        </p:spPr>
-        <p:style>
-          <a:lnRef idx="1">
-            <a:schemeClr val="accent1"/>
-          </a:lnRef>
-          <a:fillRef idx="3">
-            <a:schemeClr val="accent1"/>
-          </a:fillRef>
-          <a:effectRef idx="2">
-            <a:schemeClr val="accent1"/>
-          </a:effectRef>
-          <a:fontRef idx="minor">
-            <a:schemeClr val="lt1"/>
-          </a:fontRef>
-        </p:style>
-        <p:txBody>
-          <a:bodyPr rtlCol="0" anchor="ctr"/>
-          <a:lstStyle/>
-          <a:p>
-            <a:pPr algn="ctr"/>
-          </a:p>
-        </p:txBody>
-      </p:sp>
+              <a:t>이 모델은 2026년 60%+ 추론 GW를 fact로 취급하지 않는다.</a:t>
+            </a:r>
+          </a:p>
+        </p:txBody>
+      </p:sp>
+      <p:graphicFrame>
+        <p:nvGraphicFramePr>
+          <p:cNvPr id="4" name="Chart 3"/>
+          <p:cNvGraphicFramePr>
+            <a:graphicFrameLocks noGrp="1"/>
+          </p:cNvGraphicFramePr>
+          <p:nvPr/>
+        </p:nvGraphicFramePr>
+        <p:xfrm>
+          <a:off x="731520" y="1234440"/>
+          <a:ext cx="6583680" cy="4160520"/>
+        </p:xfrm>
+        <a:graphic>
+          <a:graphicData uri="http://schemas.openxmlformats.org/drawingml/2006/chart">
+            <c:chart xmlns:c="http://schemas.openxmlformats.org/drawingml/2006/chart" r:id="rId2"/>
+          </a:graphicData>
+        </a:graphic>
+      </p:graphicFrame>
       <p:sp>
         <p:nvSpPr>
           <p:cNvPr id="5" name="TextBox 4"/>
@@ -8883,8 +10899,8 @@
         </p:nvSpPr>
         <p:spPr>
           <a:xfrm>
-            <a:off x="896112" y="1444752"/>
-            <a:ext cx="2926080" cy="292608"/>
+            <a:off x="7726679" y="1325880"/>
+            <a:ext cx="3611880" cy="3657600"/>
           </a:xfrm>
           <a:prstGeom prst="rect">
             <a:avLst/>
@@ -8892,20 +10908,68 @@
           <a:noFill/>
         </p:spPr>
         <p:txBody>
-          <a:bodyPr wrap="none" lIns="0" rIns="0" tIns="0" bIns="0">
+          <a:bodyPr wrap="none">
             <a:spAutoFit/>
           </a:bodyPr>
           <a:lstStyle/>
           <a:p>
-            <a:pPr algn="l">
-              <a:defRPr sz="1300" b="1">
-                <a:solidFill>
-                  <a:srgbClr val="122037"/>
-                </a:solidFill>
-              </a:defRPr>
-            </a:pPr>
-            <a:r>
-              <a:t>미국 대형 플랫폼</a:t>
+            <a:pPr>
+              <a:spcAft>
+                <a:spcPts val="800"/>
+              </a:spcAft>
+              <a:defRPr sz="1300">
+                <a:solidFill>
+                  <a:srgbClr val="1E293B"/>
+                </a:solidFill>
+              </a:defRPr>
+            </a:pPr>
+            <a:r>
+              <a:t>기준 2026: 56%, 60% 미만.</a:t>
+            </a:r>
+          </a:p>
+          <a:p>
+            <a:pPr>
+              <a:spcAft>
+                <a:spcPts val="800"/>
+              </a:spcAft>
+              <a:defRPr sz="1300">
+                <a:solidFill>
+                  <a:srgbClr val="1E293B"/>
+                </a:solidFill>
+              </a:defRPr>
+            </a:pPr>
+            <a:r>
+              <a:t>낙관 2026: 61%, upside scenario에서만 허용.</a:t>
+            </a:r>
+          </a:p>
+          <a:p>
+            <a:pPr>
+              <a:spcAft>
+                <a:spcPts val="800"/>
+              </a:spcAft>
+              <a:defRPr sz="1300">
+                <a:solidFill>
+                  <a:srgbClr val="1E293B"/>
+                </a:solidFill>
+              </a:defRPr>
+            </a:pPr>
+            <a:r>
+              <a:t>기준 2030: 76%, 상용 serving 확대 반영.</a:t>
+            </a:r>
+          </a:p>
+          <a:p>
+            <a:pPr>
+              <a:spcAft>
+                <a:spcPts val="800"/>
+              </a:spcAft>
+              <a:defRPr sz="1300">
+                <a:solidFill>
+                  <a:srgbClr val="1E293B"/>
+                </a:solidFill>
+              </a:defRPr>
+            </a:pPr>
+            <a:r>
+              <a:t>모든 case에서 학습 capacity는 계속 유의미하게 남김.</a:t>
             </a:r>
           </a:p>
         </p:txBody>
@@ -8913,726 +10977,6 @@
       <p:sp>
         <p:nvSpPr>
           <p:cNvPr id="6" name="TextBox 5"/>
-          <p:cNvSpPr txBox="1"/>
-          <p:nvPr/>
-        </p:nvSpPr>
-        <p:spPr>
-          <a:xfrm>
-            <a:off x="932688" y="1993392"/>
-            <a:ext cx="2834640" cy="237744"/>
-          </a:xfrm>
-          <a:prstGeom prst="rect">
-            <a:avLst/>
-          </a:prstGeom>
-          <a:noFill/>
-        </p:spPr>
-        <p:txBody>
-          <a:bodyPr wrap="none" lIns="0" rIns="0" tIns="0" bIns="0">
-            <a:spAutoFit/>
-          </a:bodyPr>
-          <a:lstStyle/>
-          <a:p>
-            <a:pPr algn="l">
-              <a:defRPr sz="1300" b="1">
-                <a:solidFill>
-                  <a:srgbClr val="1E293B"/>
-                </a:solidFill>
-              </a:defRPr>
-            </a:pPr>
-            <a:r>
-              <a:t>OpenAI</a:t>
-            </a:r>
-          </a:p>
-        </p:txBody>
-      </p:sp>
-      <p:sp>
-        <p:nvSpPr>
-          <p:cNvPr id="7" name="TextBox 6"/>
-          <p:cNvSpPr txBox="1"/>
-          <p:nvPr/>
-        </p:nvSpPr>
-        <p:spPr>
-          <a:xfrm>
-            <a:off x="932688" y="2267712"/>
-            <a:ext cx="2834640" cy="256032"/>
-          </a:xfrm>
-          <a:prstGeom prst="rect">
-            <a:avLst/>
-          </a:prstGeom>
-          <a:noFill/>
-        </p:spPr>
-        <p:txBody>
-          <a:bodyPr wrap="none" lIns="0" rIns="0" tIns="0" bIns="0">
-            <a:spAutoFit/>
-          </a:bodyPr>
-          <a:lstStyle/>
-          <a:p>
-            <a:pPr algn="l">
-              <a:defRPr sz="830" b="0">
-                <a:solidFill>
-                  <a:srgbClr val="64748B"/>
-                </a:solidFill>
-              </a:defRPr>
-            </a:pPr>
-            <a:r>
-              <a:t>GPT / o-series / ChatGPT</a:t>
-            </a:r>
-          </a:p>
-        </p:txBody>
-      </p:sp>
-      <p:sp>
-        <p:nvSpPr>
-          <p:cNvPr id="8" name="TextBox 7"/>
-          <p:cNvSpPr txBox="1"/>
-          <p:nvPr/>
-        </p:nvSpPr>
-        <p:spPr>
-          <a:xfrm>
-            <a:off x="932688" y="2743200"/>
-            <a:ext cx="2834640" cy="237744"/>
-          </a:xfrm>
-          <a:prstGeom prst="rect">
-            <a:avLst/>
-          </a:prstGeom>
-          <a:noFill/>
-        </p:spPr>
-        <p:txBody>
-          <a:bodyPr wrap="none" lIns="0" rIns="0" tIns="0" bIns="0">
-            <a:spAutoFit/>
-          </a:bodyPr>
-          <a:lstStyle/>
-          <a:p>
-            <a:pPr algn="l">
-              <a:defRPr sz="1300" b="1">
-                <a:solidFill>
-                  <a:srgbClr val="1E293B"/>
-                </a:solidFill>
-              </a:defRPr>
-            </a:pPr>
-            <a:r>
-              <a:t>Google</a:t>
-            </a:r>
-          </a:p>
-        </p:txBody>
-      </p:sp>
-      <p:sp>
-        <p:nvSpPr>
-          <p:cNvPr id="9" name="TextBox 8"/>
-          <p:cNvSpPr txBox="1"/>
-          <p:nvPr/>
-        </p:nvSpPr>
-        <p:spPr>
-          <a:xfrm>
-            <a:off x="932688" y="3017520"/>
-            <a:ext cx="2834640" cy="256032"/>
-          </a:xfrm>
-          <a:prstGeom prst="rect">
-            <a:avLst/>
-          </a:prstGeom>
-          <a:noFill/>
-        </p:spPr>
-        <p:txBody>
-          <a:bodyPr wrap="none" lIns="0" rIns="0" tIns="0" bIns="0">
-            <a:spAutoFit/>
-          </a:bodyPr>
-          <a:lstStyle/>
-          <a:p>
-            <a:pPr algn="l">
-              <a:defRPr sz="830" b="0">
-                <a:solidFill>
-                  <a:srgbClr val="64748B"/>
-                </a:solidFill>
-              </a:defRPr>
-            </a:pPr>
-            <a:r>
-              <a:t>Gemini / Gemma</a:t>
-            </a:r>
-          </a:p>
-        </p:txBody>
-      </p:sp>
-      <p:sp>
-        <p:nvSpPr>
-          <p:cNvPr id="10" name="TextBox 9"/>
-          <p:cNvSpPr txBox="1"/>
-          <p:nvPr/>
-        </p:nvSpPr>
-        <p:spPr>
-          <a:xfrm>
-            <a:off x="932688" y="3493008"/>
-            <a:ext cx="2834640" cy="237744"/>
-          </a:xfrm>
-          <a:prstGeom prst="rect">
-            <a:avLst/>
-          </a:prstGeom>
-          <a:noFill/>
-        </p:spPr>
-        <p:txBody>
-          <a:bodyPr wrap="none" lIns="0" rIns="0" tIns="0" bIns="0">
-            <a:spAutoFit/>
-          </a:bodyPr>
-          <a:lstStyle/>
-          <a:p>
-            <a:pPr algn="l">
-              <a:defRPr sz="1300" b="1">
-                <a:solidFill>
-                  <a:srgbClr val="1E293B"/>
-                </a:solidFill>
-              </a:defRPr>
-            </a:pPr>
-            <a:r>
-              <a:t>Meta</a:t>
-            </a:r>
-          </a:p>
-        </p:txBody>
-      </p:sp>
-      <p:sp>
-        <p:nvSpPr>
-          <p:cNvPr id="11" name="TextBox 10"/>
-          <p:cNvSpPr txBox="1"/>
-          <p:nvPr/>
-        </p:nvSpPr>
-        <p:spPr>
-          <a:xfrm>
-            <a:off x="932688" y="3767328"/>
-            <a:ext cx="2834640" cy="256032"/>
-          </a:xfrm>
-          <a:prstGeom prst="rect">
-            <a:avLst/>
-          </a:prstGeom>
-          <a:noFill/>
-        </p:spPr>
-        <p:txBody>
-          <a:bodyPr wrap="none" lIns="0" rIns="0" tIns="0" bIns="0">
-            <a:spAutoFit/>
-          </a:bodyPr>
-          <a:lstStyle/>
-          <a:p>
-            <a:pPr algn="l">
-              <a:defRPr sz="830" b="0">
-                <a:solidFill>
-                  <a:srgbClr val="64748B"/>
-                </a:solidFill>
-              </a:defRPr>
-            </a:pPr>
-            <a:r>
-              <a:t>Llama / Meta AI</a:t>
-            </a:r>
-          </a:p>
-        </p:txBody>
-      </p:sp>
-      <p:sp>
-        <p:nvSpPr>
-          <p:cNvPr id="12" name="TextBox 11"/>
-          <p:cNvSpPr txBox="1"/>
-          <p:nvPr/>
-        </p:nvSpPr>
-        <p:spPr>
-          <a:xfrm>
-            <a:off x="932688" y="4242816"/>
-            <a:ext cx="2834640" cy="237744"/>
-          </a:xfrm>
-          <a:prstGeom prst="rect">
-            <a:avLst/>
-          </a:prstGeom>
-          <a:noFill/>
-        </p:spPr>
-        <p:txBody>
-          <a:bodyPr wrap="none" lIns="0" rIns="0" tIns="0" bIns="0">
-            <a:spAutoFit/>
-          </a:bodyPr>
-          <a:lstStyle/>
-          <a:p>
-            <a:pPr algn="l">
-              <a:defRPr sz="1300" b="1">
-                <a:solidFill>
-                  <a:srgbClr val="1E293B"/>
-                </a:solidFill>
-              </a:defRPr>
-            </a:pPr>
-            <a:r>
-              <a:t>Microsoft</a:t>
-            </a:r>
-          </a:p>
-        </p:txBody>
-      </p:sp>
-      <p:sp>
-        <p:nvSpPr>
-          <p:cNvPr id="13" name="TextBox 12"/>
-          <p:cNvSpPr txBox="1"/>
-          <p:nvPr/>
-        </p:nvSpPr>
-        <p:spPr>
-          <a:xfrm>
-            <a:off x="932688" y="4517136"/>
-            <a:ext cx="2834640" cy="256032"/>
-          </a:xfrm>
-          <a:prstGeom prst="rect">
-            <a:avLst/>
-          </a:prstGeom>
-          <a:noFill/>
-        </p:spPr>
-        <p:txBody>
-          <a:bodyPr wrap="none" lIns="0" rIns="0" tIns="0" bIns="0">
-            <a:spAutoFit/>
-          </a:bodyPr>
-          <a:lstStyle/>
-          <a:p>
-            <a:pPr algn="l">
-              <a:defRPr sz="830" b="0">
-                <a:solidFill>
-                  <a:srgbClr val="64748B"/>
-                </a:solidFill>
-              </a:defRPr>
-            </a:pPr>
-            <a:r>
-              <a:t>Phi / MAI / Copilot model mix</a:t>
-            </a:r>
-          </a:p>
-        </p:txBody>
-      </p:sp>
-      <p:sp>
-        <p:nvSpPr>
-          <p:cNvPr id="14" name="Rectangle 13"/>
-          <p:cNvSpPr/>
-          <p:nvPr/>
-        </p:nvSpPr>
-        <p:spPr>
-          <a:xfrm>
-            <a:off x="4526280" y="1234440"/>
-            <a:ext cx="3337560" cy="4297680"/>
-          </a:xfrm>
-          <a:prstGeom prst="rect">
-            <a:avLst/>
-          </a:prstGeom>
-          <a:solidFill>
-            <a:srgbClr val="E8F8F0"/>
-          </a:solidFill>
-          <a:ln>
-            <a:solidFill>
-              <a:srgbClr val="DAE2EC"/>
-            </a:solidFill>
-          </a:ln>
-        </p:spPr>
-        <p:style>
-          <a:lnRef idx="1">
-            <a:schemeClr val="accent1"/>
-          </a:lnRef>
-          <a:fillRef idx="3">
-            <a:schemeClr val="accent1"/>
-          </a:fillRef>
-          <a:effectRef idx="2">
-            <a:schemeClr val="accent1"/>
-          </a:effectRef>
-          <a:fontRef idx="minor">
-            <a:schemeClr val="lt1"/>
-          </a:fontRef>
-        </p:style>
-        <p:txBody>
-          <a:bodyPr rtlCol="0" anchor="ctr"/>
-          <a:lstStyle/>
-          <a:p>
-            <a:pPr algn="ctr"/>
-          </a:p>
-        </p:txBody>
-      </p:sp>
-      <p:sp>
-        <p:nvSpPr>
-          <p:cNvPr id="15" name="TextBox 14"/>
-          <p:cNvSpPr txBox="1"/>
-          <p:nvPr/>
-        </p:nvSpPr>
-        <p:spPr>
-          <a:xfrm>
-            <a:off x="4690872" y="1444752"/>
-            <a:ext cx="2926080" cy="292608"/>
-          </a:xfrm>
-          <a:prstGeom prst="rect">
-            <a:avLst/>
-          </a:prstGeom>
-          <a:noFill/>
-        </p:spPr>
-        <p:txBody>
-          <a:bodyPr wrap="none" lIns="0" rIns="0" tIns="0" bIns="0">
-            <a:spAutoFit/>
-          </a:bodyPr>
-          <a:lstStyle/>
-          <a:p>
-            <a:pPr algn="l">
-              <a:defRPr sz="1300" b="1">
-                <a:solidFill>
-                  <a:srgbClr val="122037"/>
-                </a:solidFill>
-              </a:defRPr>
-            </a:pPr>
-            <a:r>
-              <a:t>미국 challenger</a:t>
-            </a:r>
-          </a:p>
-        </p:txBody>
-      </p:sp>
-      <p:sp>
-        <p:nvSpPr>
-          <p:cNvPr id="16" name="TextBox 15"/>
-          <p:cNvSpPr txBox="1"/>
-          <p:nvPr/>
-        </p:nvSpPr>
-        <p:spPr>
-          <a:xfrm>
-            <a:off x="4727448" y="1993392"/>
-            <a:ext cx="2834640" cy="237744"/>
-          </a:xfrm>
-          <a:prstGeom prst="rect">
-            <a:avLst/>
-          </a:prstGeom>
-          <a:noFill/>
-        </p:spPr>
-        <p:txBody>
-          <a:bodyPr wrap="none" lIns="0" rIns="0" tIns="0" bIns="0">
-            <a:spAutoFit/>
-          </a:bodyPr>
-          <a:lstStyle/>
-          <a:p>
-            <a:pPr algn="l">
-              <a:defRPr sz="1300" b="1">
-                <a:solidFill>
-                  <a:srgbClr val="1E293B"/>
-                </a:solidFill>
-              </a:defRPr>
-            </a:pPr>
-            <a:r>
-              <a:t>xAI</a:t>
-            </a:r>
-          </a:p>
-        </p:txBody>
-      </p:sp>
-      <p:sp>
-        <p:nvSpPr>
-          <p:cNvPr id="17" name="TextBox 16"/>
-          <p:cNvSpPr txBox="1"/>
-          <p:nvPr/>
-        </p:nvSpPr>
-        <p:spPr>
-          <a:xfrm>
-            <a:off x="4727448" y="2267712"/>
-            <a:ext cx="2834640" cy="256032"/>
-          </a:xfrm>
-          <a:prstGeom prst="rect">
-            <a:avLst/>
-          </a:prstGeom>
-          <a:noFill/>
-        </p:spPr>
-        <p:txBody>
-          <a:bodyPr wrap="none" lIns="0" rIns="0" tIns="0" bIns="0">
-            <a:spAutoFit/>
-          </a:bodyPr>
-          <a:lstStyle/>
-          <a:p>
-            <a:pPr algn="l">
-              <a:defRPr sz="830" b="0">
-                <a:solidFill>
-                  <a:srgbClr val="64748B"/>
-                </a:solidFill>
-              </a:defRPr>
-            </a:pPr>
-            <a:r>
-              <a:t>Grok</a:t>
-            </a:r>
-          </a:p>
-        </p:txBody>
-      </p:sp>
-      <p:sp>
-        <p:nvSpPr>
-          <p:cNvPr id="18" name="Rectangle 17"/>
-          <p:cNvSpPr/>
-          <p:nvPr/>
-        </p:nvSpPr>
-        <p:spPr>
-          <a:xfrm>
-            <a:off x="8321040" y="1234440"/>
-            <a:ext cx="3337560" cy="4297680"/>
-          </a:xfrm>
-          <a:prstGeom prst="rect">
-            <a:avLst/>
-          </a:prstGeom>
-          <a:solidFill>
-            <a:srgbClr val="FFF7E5"/>
-          </a:solidFill>
-          <a:ln>
-            <a:solidFill>
-              <a:srgbClr val="DAE2EC"/>
-            </a:solidFill>
-          </a:ln>
-        </p:spPr>
-        <p:style>
-          <a:lnRef idx="1">
-            <a:schemeClr val="accent1"/>
-          </a:lnRef>
-          <a:fillRef idx="3">
-            <a:schemeClr val="accent1"/>
-          </a:fillRef>
-          <a:effectRef idx="2">
-            <a:schemeClr val="accent1"/>
-          </a:effectRef>
-          <a:fontRef idx="minor">
-            <a:schemeClr val="lt1"/>
-          </a:fontRef>
-        </p:style>
-        <p:txBody>
-          <a:bodyPr rtlCol="0" anchor="ctr"/>
-          <a:lstStyle/>
-          <a:p>
-            <a:pPr algn="ctr"/>
-          </a:p>
-        </p:txBody>
-      </p:sp>
-      <p:sp>
-        <p:nvSpPr>
-          <p:cNvPr id="19" name="TextBox 18"/>
-          <p:cNvSpPr txBox="1"/>
-          <p:nvPr/>
-        </p:nvSpPr>
-        <p:spPr>
-          <a:xfrm>
-            <a:off x="8485632" y="1444752"/>
-            <a:ext cx="2926080" cy="292608"/>
-          </a:xfrm>
-          <a:prstGeom prst="rect">
-            <a:avLst/>
-          </a:prstGeom>
-          <a:noFill/>
-        </p:spPr>
-        <p:txBody>
-          <a:bodyPr wrap="none" lIns="0" rIns="0" tIns="0" bIns="0">
-            <a:spAutoFit/>
-          </a:bodyPr>
-          <a:lstStyle/>
-          <a:p>
-            <a:pPr algn="l">
-              <a:defRPr sz="1300" b="1">
-                <a:solidFill>
-                  <a:srgbClr val="122037"/>
-                </a:solidFill>
-              </a:defRPr>
-            </a:pPr>
-            <a:r>
-              <a:t>중국 model owner</a:t>
-            </a:r>
-          </a:p>
-        </p:txBody>
-      </p:sp>
-      <p:sp>
-        <p:nvSpPr>
-          <p:cNvPr id="20" name="TextBox 19"/>
-          <p:cNvSpPr txBox="1"/>
-          <p:nvPr/>
-        </p:nvSpPr>
-        <p:spPr>
-          <a:xfrm>
-            <a:off x="8522208" y="1993392"/>
-            <a:ext cx="2834640" cy="237744"/>
-          </a:xfrm>
-          <a:prstGeom prst="rect">
-            <a:avLst/>
-          </a:prstGeom>
-          <a:noFill/>
-        </p:spPr>
-        <p:txBody>
-          <a:bodyPr wrap="none" lIns="0" rIns="0" tIns="0" bIns="0">
-            <a:spAutoFit/>
-          </a:bodyPr>
-          <a:lstStyle/>
-          <a:p>
-            <a:pPr algn="l">
-              <a:defRPr sz="1300" b="1">
-                <a:solidFill>
-                  <a:srgbClr val="1E293B"/>
-                </a:solidFill>
-              </a:defRPr>
-            </a:pPr>
-            <a:r>
-              <a:t>DeepSeek</a:t>
-            </a:r>
-          </a:p>
-        </p:txBody>
-      </p:sp>
-      <p:sp>
-        <p:nvSpPr>
-          <p:cNvPr id="21" name="TextBox 20"/>
-          <p:cNvSpPr txBox="1"/>
-          <p:nvPr/>
-        </p:nvSpPr>
-        <p:spPr>
-          <a:xfrm>
-            <a:off x="8522208" y="2267712"/>
-            <a:ext cx="2834640" cy="256032"/>
-          </a:xfrm>
-          <a:prstGeom prst="rect">
-            <a:avLst/>
-          </a:prstGeom>
-          <a:noFill/>
-        </p:spPr>
-        <p:txBody>
-          <a:bodyPr wrap="none" lIns="0" rIns="0" tIns="0" bIns="0">
-            <a:spAutoFit/>
-          </a:bodyPr>
-          <a:lstStyle/>
-          <a:p>
-            <a:pPr algn="l">
-              <a:defRPr sz="830" b="0">
-                <a:solidFill>
-                  <a:srgbClr val="64748B"/>
-                </a:solidFill>
-              </a:defRPr>
-            </a:pPr>
-            <a:r>
-              <a:t>DeepSeek-V3 / R1</a:t>
-            </a:r>
-          </a:p>
-        </p:txBody>
-      </p:sp>
-      <p:sp>
-        <p:nvSpPr>
-          <p:cNvPr id="22" name="TextBox 21"/>
-          <p:cNvSpPr txBox="1"/>
-          <p:nvPr/>
-        </p:nvSpPr>
-        <p:spPr>
-          <a:xfrm>
-            <a:off x="8522208" y="2743200"/>
-            <a:ext cx="2834640" cy="237744"/>
-          </a:xfrm>
-          <a:prstGeom prst="rect">
-            <a:avLst/>
-          </a:prstGeom>
-          <a:noFill/>
-        </p:spPr>
-        <p:txBody>
-          <a:bodyPr wrap="none" lIns="0" rIns="0" tIns="0" bIns="0">
-            <a:spAutoFit/>
-          </a:bodyPr>
-          <a:lstStyle/>
-          <a:p>
-            <a:pPr algn="l">
-              <a:defRPr sz="1300" b="1">
-                <a:solidFill>
-                  <a:srgbClr val="1E293B"/>
-                </a:solidFill>
-              </a:defRPr>
-            </a:pPr>
-            <a:r>
-              <a:t>Alibaba</a:t>
-            </a:r>
-          </a:p>
-        </p:txBody>
-      </p:sp>
-      <p:sp>
-        <p:nvSpPr>
-          <p:cNvPr id="23" name="TextBox 22"/>
-          <p:cNvSpPr txBox="1"/>
-          <p:nvPr/>
-        </p:nvSpPr>
-        <p:spPr>
-          <a:xfrm>
-            <a:off x="8522208" y="3017520"/>
-            <a:ext cx="2834640" cy="256032"/>
-          </a:xfrm>
-          <a:prstGeom prst="rect">
-            <a:avLst/>
-          </a:prstGeom>
-          <a:noFill/>
-        </p:spPr>
-        <p:txBody>
-          <a:bodyPr wrap="none" lIns="0" rIns="0" tIns="0" bIns="0">
-            <a:spAutoFit/>
-          </a:bodyPr>
-          <a:lstStyle/>
-          <a:p>
-            <a:pPr algn="l">
-              <a:defRPr sz="830" b="0">
-                <a:solidFill>
-                  <a:srgbClr val="64748B"/>
-                </a:solidFill>
-              </a:defRPr>
-            </a:pPr>
-            <a:r>
-              <a:t>Qwen / Qwen3</a:t>
-            </a:r>
-          </a:p>
-        </p:txBody>
-      </p:sp>
-      <p:sp>
-        <p:nvSpPr>
-          <p:cNvPr id="24" name="TextBox 23"/>
-          <p:cNvSpPr txBox="1"/>
-          <p:nvPr/>
-        </p:nvSpPr>
-        <p:spPr>
-          <a:xfrm>
-            <a:off x="8522208" y="3493008"/>
-            <a:ext cx="2834640" cy="237744"/>
-          </a:xfrm>
-          <a:prstGeom prst="rect">
-            <a:avLst/>
-          </a:prstGeom>
-          <a:noFill/>
-        </p:spPr>
-        <p:txBody>
-          <a:bodyPr wrap="none" lIns="0" rIns="0" tIns="0" bIns="0">
-            <a:spAutoFit/>
-          </a:bodyPr>
-          <a:lstStyle/>
-          <a:p>
-            <a:pPr algn="l">
-              <a:defRPr sz="1300" b="1">
-                <a:solidFill>
-                  <a:srgbClr val="1E293B"/>
-                </a:solidFill>
-              </a:defRPr>
-            </a:pPr>
-            <a:r>
-              <a:t>Tencent</a:t>
-            </a:r>
-          </a:p>
-        </p:txBody>
-      </p:sp>
-      <p:sp>
-        <p:nvSpPr>
-          <p:cNvPr id="25" name="TextBox 24"/>
-          <p:cNvSpPr txBox="1"/>
-          <p:nvPr/>
-        </p:nvSpPr>
-        <p:spPr>
-          <a:xfrm>
-            <a:off x="8522208" y="3767328"/>
-            <a:ext cx="2834640" cy="256032"/>
-          </a:xfrm>
-          <a:prstGeom prst="rect">
-            <a:avLst/>
-          </a:prstGeom>
-          <a:noFill/>
-        </p:spPr>
-        <p:txBody>
-          <a:bodyPr wrap="none" lIns="0" rIns="0" tIns="0" bIns="0">
-            <a:spAutoFit/>
-          </a:bodyPr>
-          <a:lstStyle/>
-          <a:p>
-            <a:pPr algn="l">
-              <a:defRPr sz="830" b="0">
-                <a:solidFill>
-                  <a:srgbClr val="64748B"/>
-                </a:solidFill>
-              </a:defRPr>
-            </a:pPr>
-            <a:r>
-              <a:t>Hunyuan / Hy3 / Yuanbao</a:t>
-            </a:r>
-          </a:p>
-        </p:txBody>
-      </p:sp>
-      <p:sp>
-        <p:nvSpPr>
-          <p:cNvPr id="26" name="TextBox 25"/>
           <p:cNvSpPr txBox="1"/>
           <p:nvPr/>
         </p:nvSpPr>

</xml_diff>